<commit_message>
Update Variables Literals and Types lecture slides
</commit_message>
<xml_diff>
--- a/lectures/03-Variables-Literals-Types/CS1910_Variables-Literals-Types_Lecture.pptx
+++ b/lectures/03-Variables-Literals-Types/CS1910_Variables-Literals-Types_Lecture.pptx
@@ -8,11 +8,11 @@
     <p:notesMasterId r:id="rId38"/>
   </p:notesMasterIdLst>
   <p:sldIdLst>
-    <p:sldId id="256" r:id="rId2"/>
-    <p:sldId id="257" r:id="rId3"/>
-    <p:sldId id="344" r:id="rId4"/>
-    <p:sldId id="345" r:id="rId5"/>
-    <p:sldId id="340" r:id="rId6"/>
+    <p:sldId id="346" r:id="rId2"/>
+    <p:sldId id="256" r:id="rId3"/>
+    <p:sldId id="257" r:id="rId4"/>
+    <p:sldId id="344" r:id="rId5"/>
+    <p:sldId id="345" r:id="rId6"/>
     <p:sldId id="318" r:id="rId7"/>
     <p:sldId id="319" r:id="rId8"/>
     <p:sldId id="320" r:id="rId9"/>
@@ -153,40 +153,95 @@
 <file path=ppt/changesInfos/changesInfo1.xml><?xml version="1.0" encoding="utf-8"?>
 <pc:chgInfo xmlns:a="http://schemas.openxmlformats.org/drawingml/2006/main" xmlns:r="http://schemas.openxmlformats.org/officeDocument/2006/relationships" xmlns:ac="http://schemas.microsoft.com/office/drawing/2013/main/command" xmlns:pc="http://schemas.microsoft.com/office/powerpoint/2013/main/command">
   <pc:docChgLst>
-    <pc:chgData name="Christopher Power" userId="83706efc-52ec-4aad-b93a-e27c6e901a30" providerId="ADAL" clId="{97D26654-64D5-4042-8583-A5886BB6B01E}"/>
-    <pc:docChg chg="undo custSel addSld delSld modSld">
-      <pc:chgData name="Christopher Power" userId="83706efc-52ec-4aad-b93a-e27c6e901a30" providerId="ADAL" clId="{97D26654-64D5-4042-8583-A5886BB6B01E}" dt="2026-07-23T00:11:23.901" v="5838" actId="20577"/>
+    <pc:chgData name="Christopher Power" userId="83706efc-52ec-4aad-b93a-e27c6e901a30" providerId="ADAL" clId="{020B0DAE-24A7-40F8-9A5C-565589CDAAC4}"/>
+    <pc:docChg chg="custSel addSld delSld modSld">
+      <pc:chgData name="Christopher Power" userId="83706efc-52ec-4aad-b93a-e27c6e901a30" providerId="ADAL" clId="{020B0DAE-24A7-40F8-9A5C-565589CDAAC4}" dt="2026-09-03T19:35:24.537" v="19" actId="700"/>
       <pc:docMkLst>
         <pc:docMk/>
       </pc:docMkLst>
-      <pc:sldChg chg="modSp mod">
-        <pc:chgData name="Christopher Power" userId="83706efc-52ec-4aad-b93a-e27c6e901a30" providerId="ADAL" clId="{97D26654-64D5-4042-8583-A5886BB6B01E}" dt="2026-07-23T00:11:23.901" v="5838" actId="20577"/>
+      <pc:sldChg chg="del">
+        <pc:chgData name="Christopher Power" userId="83706efc-52ec-4aad-b93a-e27c6e901a30" providerId="ADAL" clId="{020B0DAE-24A7-40F8-9A5C-565589CDAAC4}" dt="2026-09-03T19:35:11.671" v="17" actId="47"/>
         <pc:sldMkLst>
           <pc:docMk/>
-          <pc:sldMk cId="3002068836" sldId="256"/>
+          <pc:sldMk cId="2938145428" sldId="340"/>
+        </pc:sldMkLst>
+      </pc:sldChg>
+      <pc:sldChg chg="modSp mod">
+        <pc:chgData name="Christopher Power" userId="83706efc-52ec-4aad-b93a-e27c6e901a30" providerId="ADAL" clId="{020B0DAE-24A7-40F8-9A5C-565589CDAAC4}" dt="2026-09-03T19:34:07.854" v="16" actId="27636"/>
+        <pc:sldMkLst>
+          <pc:docMk/>
+          <pc:sldMk cId="1670994567" sldId="344"/>
         </pc:sldMkLst>
         <pc:spChg chg="mod">
-          <ac:chgData name="Christopher Power" userId="83706efc-52ec-4aad-b93a-e27c6e901a30" providerId="ADAL" clId="{97D26654-64D5-4042-8583-A5886BB6B01E}" dt="2026-07-23T00:11:23.901" v="5838" actId="20577"/>
+          <ac:chgData name="Christopher Power" userId="83706efc-52ec-4aad-b93a-e27c6e901a30" providerId="ADAL" clId="{020B0DAE-24A7-40F8-9A5C-565589CDAAC4}" dt="2026-09-03T19:34:07.854" v="16" actId="27636"/>
           <ac:spMkLst>
             <pc:docMk/>
-            <pc:sldMk cId="3002068836" sldId="256"/>
-            <ac:spMk id="3" creationId="{C5AB9C7C-BEF1-C07A-6A77-DBDD71480AAD}"/>
+            <pc:sldMk cId="1670994567" sldId="344"/>
+            <ac:spMk id="4" creationId="{2AAC0547-68BD-8F6C-9B5C-89D882DB3754}"/>
           </ac:spMkLst>
         </pc:spChg>
       </pc:sldChg>
-      <pc:sldChg chg="addSp modSp del mod">
-        <pc:chgData name="Christopher Power" userId="83706efc-52ec-4aad-b93a-e27c6e901a30" providerId="ADAL" clId="{97D26654-64D5-4042-8583-A5886BB6B01E}" dt="2026-07-23T00:11:11.981" v="5798" actId="47"/>
+      <pc:sldChg chg="modSp mod">
+        <pc:chgData name="Christopher Power" userId="83706efc-52ec-4aad-b93a-e27c6e901a30" providerId="ADAL" clId="{020B0DAE-24A7-40F8-9A5C-565589CDAAC4}" dt="2026-09-03T19:34:02.085" v="14" actId="27636"/>
         <pc:sldMkLst>
           <pc:docMk/>
-          <pc:sldMk cId="1144124753" sldId="266"/>
+          <pc:sldMk cId="211227348" sldId="345"/>
         </pc:sldMkLst>
+        <pc:spChg chg="mod">
+          <ac:chgData name="Christopher Power" userId="83706efc-52ec-4aad-b93a-e27c6e901a30" providerId="ADAL" clId="{020B0DAE-24A7-40F8-9A5C-565589CDAAC4}" dt="2026-09-03T19:34:02.085" v="14" actId="27636"/>
+          <ac:spMkLst>
+            <pc:docMk/>
+            <pc:sldMk cId="211227348" sldId="345"/>
+            <ac:spMk id="4" creationId="{FD203C1E-997C-E23D-9AB2-D4FAB570F42B}"/>
+          </ac:spMkLst>
+        </pc:spChg>
+        <pc:spChg chg="mod">
+          <ac:chgData name="Christopher Power" userId="83706efc-52ec-4aad-b93a-e27c6e901a30" providerId="ADAL" clId="{020B0DAE-24A7-40F8-9A5C-565589CDAAC4}" dt="2026-09-03T19:34:02.085" v="13" actId="27636"/>
+          <ac:spMkLst>
+            <pc:docMk/>
+            <pc:sldMk cId="211227348" sldId="345"/>
+            <ac:spMk id="5" creationId="{9EFF568E-1DA6-057D-DB39-9673069A4DCC}"/>
+          </ac:spMkLst>
+        </pc:spChg>
       </pc:sldChg>
-      <pc:sldChg chg="addSp delSp modSp new del mod modShow">
-        <pc:chgData name="Christopher Power" userId="83706efc-52ec-4aad-b93a-e27c6e901a30" providerId="ADAL" clId="{97D26654-64D5-4042-8583-A5886BB6B01E}" dt="2026-07-23T00:11:12.556" v="5799" actId="47"/>
+      <pc:sldChg chg="addSp delSp modSp new mod chgLayout">
+        <pc:chgData name="Christopher Power" userId="83706efc-52ec-4aad-b93a-e27c6e901a30" providerId="ADAL" clId="{020B0DAE-24A7-40F8-9A5C-565589CDAAC4}" dt="2026-09-03T19:35:24.537" v="19" actId="700"/>
         <pc:sldMkLst>
           <pc:docMk/>
-          <pc:sldMk cId="662383138" sldId="343"/>
+          <pc:sldMk cId="1441734341" sldId="346"/>
         </pc:sldMkLst>
+        <pc:spChg chg="del mod ord">
+          <ac:chgData name="Christopher Power" userId="83706efc-52ec-4aad-b93a-e27c6e901a30" providerId="ADAL" clId="{020B0DAE-24A7-40F8-9A5C-565589CDAAC4}" dt="2026-09-03T19:35:24.537" v="19" actId="700"/>
+          <ac:spMkLst>
+            <pc:docMk/>
+            <pc:sldMk cId="1441734341" sldId="346"/>
+            <ac:spMk id="2" creationId="{84FE4F11-01F6-1AE2-D19B-F3A6B0DCDE28}"/>
+          </ac:spMkLst>
+        </pc:spChg>
+        <pc:spChg chg="del mod ord">
+          <ac:chgData name="Christopher Power" userId="83706efc-52ec-4aad-b93a-e27c6e901a30" providerId="ADAL" clId="{020B0DAE-24A7-40F8-9A5C-565589CDAAC4}" dt="2026-09-03T19:35:24.537" v="19" actId="700"/>
+          <ac:spMkLst>
+            <pc:docMk/>
+            <pc:sldMk cId="1441734341" sldId="346"/>
+            <ac:spMk id="3" creationId="{08572B9A-2E18-0F61-02C8-A2B3C27A99C4}"/>
+          </ac:spMkLst>
+        </pc:spChg>
+        <pc:spChg chg="add mod ord">
+          <ac:chgData name="Christopher Power" userId="83706efc-52ec-4aad-b93a-e27c6e901a30" providerId="ADAL" clId="{020B0DAE-24A7-40F8-9A5C-565589CDAAC4}" dt="2026-09-03T19:35:24.537" v="19" actId="700"/>
+          <ac:spMkLst>
+            <pc:docMk/>
+            <pc:sldMk cId="1441734341" sldId="346"/>
+            <ac:spMk id="4" creationId="{09B2CEB9-7CDB-6527-0097-91E4182AA377}"/>
+          </ac:spMkLst>
+        </pc:spChg>
+        <pc:spChg chg="add mod ord">
+          <ac:chgData name="Christopher Power" userId="83706efc-52ec-4aad-b93a-e27c6e901a30" providerId="ADAL" clId="{020B0DAE-24A7-40F8-9A5C-565589CDAAC4}" dt="2026-09-03T19:35:24.537" v="19" actId="700"/>
+          <ac:spMkLst>
+            <pc:docMk/>
+            <pc:sldMk cId="1441734341" sldId="346"/>
+            <ac:spMk id="5" creationId="{7EAEFB34-A5B5-F874-5D40-3B13BCF10EF9}"/>
+          </ac:spMkLst>
+        </pc:spChg>
       </pc:sldChg>
     </pc:docChg>
   </pc:docChgLst>
@@ -275,7 +330,7 @@
           <a:p>
             <a:fld id="{34AA4B8C-BF6B-4440-8121-9D39C04872C3}" type="datetimeFigureOut">
               <a:rPr lang="en-US" smtClean="0"/>
-              <a:t>7/22/2026</a:t>
+              <a:t>9/3/2026</a:t>
             </a:fld>
             <a:endParaRPr lang="en-US"/>
           </a:p>
@@ -792,7 +847,7 @@
           <a:p>
             <a:fld id="{1160EA64-D806-43AC-9DF2-F8C432F32B4C}" type="datetimeFigureOut">
               <a:rPr lang="en-US" dirty="0"/>
-              <a:t>7/22/2026</a:t>
+              <a:t>9/3/2026</a:t>
             </a:fld>
             <a:endParaRPr lang="en-US" dirty="0"/>
           </a:p>
@@ -958,7 +1013,7 @@
           <a:p>
             <a:fld id="{E9F9C37B-1D36-470B-8223-D6C91242EC14}" type="datetimeFigureOut">
               <a:rPr lang="en-US" dirty="0"/>
-              <a:t>7/22/2026</a:t>
+              <a:t>9/3/2026</a:t>
             </a:fld>
             <a:endParaRPr lang="en-US" dirty="0"/>
           </a:p>
@@ -1133,7 +1188,7 @@
           <a:p>
             <a:fld id="{67C6F52A-A82B-47A2-A83A-8C4C91F2D59F}" type="datetimeFigureOut">
               <a:rPr lang="en-US" dirty="0"/>
-              <a:t>7/22/2026</a:t>
+              <a:t>9/3/2026</a:t>
             </a:fld>
             <a:endParaRPr lang="en-US" dirty="0"/>
           </a:p>
@@ -1298,7 +1353,7 @@
           <a:p>
             <a:fld id="{F070A7B3-6521-4DCA-87E5-044747A908C1}" type="datetimeFigureOut">
               <a:rPr lang="en-US" dirty="0"/>
-              <a:t>7/22/2026</a:t>
+              <a:t>9/3/2026</a:t>
             </a:fld>
             <a:endParaRPr lang="en-US" dirty="0"/>
           </a:p>
@@ -1562,7 +1617,7 @@
           <a:p>
             <a:fld id="{1160EA64-D806-43AC-9DF2-F8C432F32B4C}" type="datetimeFigureOut">
               <a:rPr lang="en-US" dirty="0"/>
-              <a:t>7/22/2026</a:t>
+              <a:t>9/3/2026</a:t>
             </a:fld>
             <a:endParaRPr lang="en-US" dirty="0"/>
           </a:p>
@@ -1790,7 +1845,7 @@
           <a:p>
             <a:fld id="{AB134690-1557-4C89-A502-4959FE7FAD70}" type="datetimeFigureOut">
               <a:rPr lang="en-US" dirty="0"/>
-              <a:t>7/22/2026</a:t>
+              <a:t>9/3/2026</a:t>
             </a:fld>
             <a:endParaRPr lang="en-US" dirty="0"/>
           </a:p>
@@ -2144,7 +2199,7 @@
           <a:p>
             <a:fld id="{4F7D4976-E339-4826-83B7-FBD03F55ECF8}" type="datetimeFigureOut">
               <a:rPr lang="en-US" dirty="0"/>
-              <a:t>7/22/2026</a:t>
+              <a:t>9/3/2026</a:t>
             </a:fld>
             <a:endParaRPr lang="en-US" dirty="0"/>
           </a:p>
@@ -2280,7 +2335,7 @@
           <a:p>
             <a:fld id="{E1037C31-9E7A-4F99-8774-A0E530DE1A42}" type="datetimeFigureOut">
               <a:rPr lang="en-US" dirty="0"/>
-              <a:t>7/22/2026</a:t>
+              <a:t>9/3/2026</a:t>
             </a:fld>
             <a:endParaRPr lang="en-US" dirty="0"/>
           </a:p>
@@ -2370,7 +2425,7 @@
           <a:p>
             <a:fld id="{C278504F-A551-4DE0-9316-4DCD1D8CC752}" type="datetimeFigureOut">
               <a:rPr lang="en-US" dirty="0"/>
-              <a:t>7/22/2026</a:t>
+              <a:t>9/3/2026</a:t>
             </a:fld>
             <a:endParaRPr lang="en-US" dirty="0"/>
           </a:p>
@@ -2722,7 +2777,7 @@
           <a:p>
             <a:fld id="{D1BE4249-C0D0-4B06-8692-E8BB871AF643}" type="datetimeFigureOut">
               <a:rPr lang="en-US" dirty="0"/>
-              <a:t>7/22/2026</a:t>
+              <a:t>9/3/2026</a:t>
             </a:fld>
             <a:endParaRPr lang="en-US" dirty="0"/>
           </a:p>
@@ -3074,7 +3129,7 @@
           <a:p>
             <a:fld id="{042B0DB6-F5C7-45FB-8CF3-31B45F9C2DAC}" type="datetimeFigureOut">
               <a:rPr lang="en-US" dirty="0"/>
-              <a:t>7/22/2026</a:t>
+              <a:t>9/3/2026</a:t>
             </a:fld>
             <a:endParaRPr lang="en-US" dirty="0"/>
           </a:p>
@@ -3311,7 +3366,7 @@
           <a:p>
             <a:fld id="{1160EA64-D806-43AC-9DF2-F8C432F32B4C}" type="datetimeFigureOut">
               <a:rPr lang="en-US" dirty="0"/>
-              <a:t>7/22/2026</a:t>
+              <a:t>9/3/2026</a:t>
             </a:fld>
             <a:endParaRPr lang="en-US" dirty="0"/>
           </a:p>
@@ -3746,14 +3801,6 @@
 <file path=ppt/slides/slide1.xml><?xml version="1.0" encoding="utf-8"?>
 <p:sld xmlns:a="http://schemas.openxmlformats.org/drawingml/2006/main" xmlns:r="http://schemas.openxmlformats.org/officeDocument/2006/relationships" xmlns:p="http://schemas.openxmlformats.org/presentationml/2006/main">
   <p:cSld>
-    <p:bg>
-      <p:bgPr>
-        <a:solidFill>
-          <a:schemeClr val="bg2"/>
-        </a:solidFill>
-        <a:effectLst/>
-      </p:bgPr>
-    </p:bg>
     <p:spTree>
       <p:nvGrpSpPr>
         <p:cNvPr id="1" name=""/>
@@ -3770,10 +3817,10 @@
       </p:grpSpPr>
       <p:sp>
         <p:nvSpPr>
-          <p:cNvPr id="2" name="Title 1">
-            <a:extLst>
-              <a:ext uri="{FF2B5EF4-FFF2-40B4-BE49-F238E27FC236}">
-                <a16:creationId xmlns:a16="http://schemas.microsoft.com/office/drawing/2014/main" id="{C93DC5BA-038A-1370-693A-933684213ED6}"/>
+          <p:cNvPr id="4" name="Title 3">
+            <a:extLst>
+              <a:ext uri="{FF2B5EF4-FFF2-40B4-BE49-F238E27FC236}">
+                <a16:creationId xmlns:a16="http://schemas.microsoft.com/office/drawing/2014/main" id="{09B2CEB9-7CDB-6527-0097-91E4182AA377}"/>
               </a:ext>
             </a:extLst>
           </p:cNvPr>
@@ -3781,109 +3828,24 @@
             <a:spLocks noGrp="1"/>
           </p:cNvSpPr>
           <p:nvPr>
-            <p:ph type="ctrTitle"/>
+            <p:ph type="title"/>
           </p:nvPr>
         </p:nvSpPr>
-        <p:spPr>
-          <a:xfrm>
-            <a:off x="965198" y="2474895"/>
-            <a:ext cx="6212764" cy="1908215"/>
-          </a:xfrm>
-          <a:noFill/>
-          <a:ln>
-            <a:solidFill>
-              <a:schemeClr val="tx1"/>
-            </a:solidFill>
-          </a:ln>
-        </p:spPr>
-        <p:txBody>
-          <a:bodyPr wrap="square">
-            <a:normAutofit/>
-          </a:bodyPr>
-          <a:lstStyle/>
-          <a:p>
-            <a:r>
-              <a:rPr lang="en-US" sz="4000">
-                <a:solidFill>
-                  <a:schemeClr val="tx1"/>
-                </a:solidFill>
-              </a:rPr>
-              <a:t>CS 1910</a:t>
-            </a:r>
-          </a:p>
-        </p:txBody>
-      </p:sp>
-      <p:sp>
-        <p:nvSpPr>
-          <p:cNvPr id="8" name="Rectangle 7">
-            <a:extLst>
-              <a:ext uri="{FF2B5EF4-FFF2-40B4-BE49-F238E27FC236}">
-                <a16:creationId xmlns:a16="http://schemas.microsoft.com/office/drawing/2014/main" id="{157A82F3-F6C4-4325-8C9C-7DF1AD06B2B5}"/>
-              </a:ext>
-              <a:ext uri="{C183D7F6-B498-43B3-948B-1728B52AA6E4}">
-                <adec:decorative xmlns:adec="http://schemas.microsoft.com/office/drawing/2017/decorative" val="1"/>
-              </a:ext>
-            </a:extLst>
-          </p:cNvPr>
-          <p:cNvSpPr>
-            <a:spLocks noGrp="1" noRot="1" noChangeAspect="1" noMove="1" noResize="1" noEditPoints="1" noAdjustHandles="1" noChangeArrowheads="1" noChangeShapeType="1" noTextEdit="1"/>
-          </p:cNvSpPr>
-          <p:nvPr>
-            <p:extLst>
-              <p:ext uri="{386F3935-93C4-4BCD-93E2-E3B085C9AB24}">
-                <p16:designElem xmlns:p16="http://schemas.microsoft.com/office/powerpoint/2015/main" val="1"/>
-              </p:ext>
-            </p:extLst>
-          </p:nvPr>
-        </p:nvSpPr>
-        <p:spPr>
-          <a:xfrm>
-            <a:off x="8129872" y="0"/>
-            <a:ext cx="4062128" cy="6858000"/>
-          </a:xfrm>
-          <a:prstGeom prst="rect">
-            <a:avLst/>
-          </a:prstGeom>
-          <a:solidFill>
-            <a:schemeClr val="bg2">
-              <a:lumMod val="75000"/>
-            </a:schemeClr>
-          </a:solidFill>
-          <a:ln>
-            <a:noFill/>
-          </a:ln>
-        </p:spPr>
-        <p:style>
-          <a:lnRef idx="2">
-            <a:schemeClr val="accent1">
-              <a:shade val="50000"/>
-            </a:schemeClr>
-          </a:lnRef>
-          <a:fillRef idx="1">
-            <a:schemeClr val="accent1"/>
-          </a:fillRef>
-          <a:effectRef idx="0">
-            <a:schemeClr val="accent1"/>
-          </a:effectRef>
-          <a:fontRef idx="minor">
-            <a:schemeClr val="lt1"/>
-          </a:fontRef>
-        </p:style>
-        <p:txBody>
-          <a:bodyPr rtlCol="0" anchor="ctr"/>
-          <a:lstStyle/>
-          <a:p>
-            <a:pPr algn="ctr"/>
-            <a:endParaRPr lang="en-US"/>
-          </a:p>
-        </p:txBody>
-      </p:sp>
-      <p:sp>
-        <p:nvSpPr>
-          <p:cNvPr id="3" name="Subtitle 2">
-            <a:extLst>
-              <a:ext uri="{FF2B5EF4-FFF2-40B4-BE49-F238E27FC236}">
-                <a16:creationId xmlns:a16="http://schemas.microsoft.com/office/drawing/2014/main" id="{C5AB9C7C-BEF1-C07A-6A77-DBDD71480AAD}"/>
+        <p:spPr/>
+        <p:txBody>
+          <a:bodyPr/>
+          <a:lstStyle/>
+          <a:p>
+            <a:endParaRPr lang="en-CA"/>
+          </a:p>
+        </p:txBody>
+      </p:sp>
+      <p:sp>
+        <p:nvSpPr>
+          <p:cNvPr id="5" name="Content Placeholder 4">
+            <a:extLst>
+              <a:ext uri="{FF2B5EF4-FFF2-40B4-BE49-F238E27FC236}">
+                <a16:creationId xmlns:a16="http://schemas.microsoft.com/office/drawing/2014/main" id="{7EAEFB34-A5B5-F874-5D40-3B13BCF10EF9}"/>
               </a:ext>
             </a:extLst>
           </p:cNvPr>
@@ -3891,67 +3853,22 @@
             <a:spLocks noGrp="1"/>
           </p:cNvSpPr>
           <p:nvPr>
-            <p:ph type="subTitle" idx="1"/>
+            <p:ph idx="1"/>
           </p:nvPr>
         </p:nvSpPr>
-        <p:spPr>
-          <a:xfrm>
-            <a:off x="8533732" y="2173266"/>
-            <a:ext cx="3254408" cy="2511468"/>
-          </a:xfrm>
-        </p:spPr>
-        <p:txBody>
-          <a:bodyPr anchor="ctr">
-            <a:normAutofit/>
-          </a:bodyPr>
-          <a:lstStyle/>
-          <a:p>
-            <a:r>
-              <a:rPr lang="en-US" sz="2400" dirty="0">
-                <a:solidFill>
-                  <a:schemeClr val="tx2">
-                    <a:lumMod val="90000"/>
-                  </a:schemeClr>
-                </a:solidFill>
-              </a:rPr>
-              <a:t>Computer </a:t>
-            </a:r>
-            <a:r>
-              <a:rPr lang="en-US" sz="2400">
-                <a:solidFill>
-                  <a:schemeClr val="tx2">
-                    <a:lumMod val="90000"/>
-                  </a:schemeClr>
-                </a:solidFill>
-              </a:rPr>
-              <a:t>Science I </a:t>
-            </a:r>
-            <a:endParaRPr lang="en-US" sz="2400" dirty="0">
-              <a:solidFill>
-                <a:schemeClr val="tx2">
-                  <a:lumMod val="90000"/>
-                </a:schemeClr>
-              </a:solidFill>
-            </a:endParaRPr>
-          </a:p>
-          <a:p>
-            <a:r>
-              <a:rPr lang="en-US" sz="2400" dirty="0">
-                <a:solidFill>
-                  <a:schemeClr val="tx2">
-                    <a:lumMod val="90000"/>
-                  </a:schemeClr>
-                </a:solidFill>
-              </a:rPr>
-              <a:t>Variables, Literals and Types</a:t>
-            </a:r>
+        <p:spPr/>
+        <p:txBody>
+          <a:bodyPr/>
+          <a:lstStyle/>
+          <a:p>
+            <a:endParaRPr lang="en-CA"/>
           </a:p>
         </p:txBody>
       </p:sp>
     </p:spTree>
     <p:extLst>
       <p:ext uri="{BB962C8B-B14F-4D97-AF65-F5344CB8AC3E}">
-        <p14:creationId xmlns:p14="http://schemas.microsoft.com/office/powerpoint/2010/main" val="3002068836"/>
+        <p14:creationId xmlns:p14="http://schemas.microsoft.com/office/powerpoint/2010/main" val="1441734341"/>
       </p:ext>
     </p:extLst>
   </p:cSld>
@@ -9122,6 +9039,14 @@
 <file path=ppt/slides/slide2.xml><?xml version="1.0" encoding="utf-8"?>
 <p:sld xmlns:a="http://schemas.openxmlformats.org/drawingml/2006/main" xmlns:r="http://schemas.openxmlformats.org/officeDocument/2006/relationships" xmlns:p="http://schemas.openxmlformats.org/presentationml/2006/main">
   <p:cSld>
+    <p:bg>
+      <p:bgPr>
+        <a:solidFill>
+          <a:schemeClr val="bg2"/>
+        </a:solidFill>
+        <a:effectLst/>
+      </p:bgPr>
+    </p:bg>
     <p:spTree>
       <p:nvGrpSpPr>
         <p:cNvPr id="1" name=""/>
@@ -9141,7 +9066,7 @@
           <p:cNvPr id="2" name="Title 1">
             <a:extLst>
               <a:ext uri="{FF2B5EF4-FFF2-40B4-BE49-F238E27FC236}">
-                <a16:creationId xmlns:a16="http://schemas.microsoft.com/office/drawing/2014/main" id="{F44AC4E3-91E1-D318-C9FD-C51C7FA7FDBA}"/>
+                <a16:creationId xmlns:a16="http://schemas.microsoft.com/office/drawing/2014/main" id="{C93DC5BA-038A-1370-693A-933684213ED6}"/>
               </a:ext>
             </a:extLst>
           </p:cNvPr>
@@ -9149,201 +9074,169 @@
             <a:spLocks noGrp="1"/>
           </p:cNvSpPr>
           <p:nvPr>
-            <p:ph type="title"/>
+            <p:ph type="ctrTitle"/>
           </p:nvPr>
         </p:nvSpPr>
         <p:spPr>
           <a:xfrm>
-            <a:off x="2225617" y="413885"/>
-            <a:ext cx="7729728" cy="1188720"/>
-          </a:xfrm>
-        </p:spPr>
-        <p:txBody>
-          <a:bodyPr/>
-          <a:lstStyle/>
-          <a:p>
-            <a:r>
-              <a:rPr lang="en-US" dirty="0"/>
-              <a:t>Try at Home Recap</a:t>
-            </a:r>
-          </a:p>
-        </p:txBody>
-      </p:sp>
-      <p:sp>
-        <p:nvSpPr>
-          <p:cNvPr id="3" name="Content Placeholder 2">
-            <a:extLst>
-              <a:ext uri="{FF2B5EF4-FFF2-40B4-BE49-F238E27FC236}">
-                <a16:creationId xmlns:a16="http://schemas.microsoft.com/office/drawing/2014/main" id="{E35AAE5B-1BEF-5BC6-978A-C5FB4386EA1F}"/>
+            <a:off x="965198" y="2474895"/>
+            <a:ext cx="6212764" cy="1908215"/>
+          </a:xfrm>
+          <a:noFill/>
+          <a:ln>
+            <a:solidFill>
+              <a:schemeClr val="tx1"/>
+            </a:solidFill>
+          </a:ln>
+        </p:spPr>
+        <p:txBody>
+          <a:bodyPr wrap="square">
+            <a:normAutofit/>
+          </a:bodyPr>
+          <a:lstStyle/>
+          <a:p>
+            <a:r>
+              <a:rPr lang="en-US" sz="4000">
+                <a:solidFill>
+                  <a:schemeClr val="tx1"/>
+                </a:solidFill>
+              </a:rPr>
+              <a:t>CS 1910</a:t>
+            </a:r>
+          </a:p>
+        </p:txBody>
+      </p:sp>
+      <p:sp>
+        <p:nvSpPr>
+          <p:cNvPr id="8" name="Rectangle 7">
+            <a:extLst>
+              <a:ext uri="{FF2B5EF4-FFF2-40B4-BE49-F238E27FC236}">
+                <a16:creationId xmlns:a16="http://schemas.microsoft.com/office/drawing/2014/main" id="{157A82F3-F6C4-4325-8C9C-7DF1AD06B2B5}"/>
+              </a:ext>
+              <a:ext uri="{C183D7F6-B498-43B3-948B-1728B52AA6E4}">
+                <adec:decorative xmlns:adec="http://schemas.microsoft.com/office/drawing/2017/decorative" val="1"/>
               </a:ext>
             </a:extLst>
           </p:cNvPr>
           <p:cNvSpPr>
-            <a:spLocks noGrp="1"/>
+            <a:spLocks noGrp="1" noRot="1" noChangeAspect="1" noMove="1" noResize="1" noEditPoints="1" noAdjustHandles="1" noChangeArrowheads="1" noChangeShapeType="1" noTextEdit="1"/>
           </p:cNvSpPr>
           <p:nvPr>
-            <p:ph idx="1"/>
+            <p:extLst>
+              <p:ext uri="{386F3935-93C4-4BCD-93E2-E3B085C9AB24}">
+                <p16:designElem xmlns:p16="http://schemas.microsoft.com/office/powerpoint/2015/main" val="1"/>
+              </p:ext>
+            </p:extLst>
           </p:nvPr>
         </p:nvSpPr>
         <p:spPr>
           <a:xfrm>
-            <a:off x="178514" y="2046514"/>
-            <a:ext cx="7729728" cy="2745743"/>
-          </a:xfrm>
-        </p:spPr>
-        <p:txBody>
-          <a:bodyPr/>
-          <a:lstStyle/>
-          <a:p>
-            <a:r>
-              <a:rPr lang="en-US" dirty="0"/>
-              <a:t>Turtle Draw – initial in name</a:t>
-            </a:r>
-          </a:p>
-          <a:p>
-            <a:r>
-              <a:rPr lang="en-US" dirty="0"/>
-              <a:t>Tinkering with the prior code – any interesting outcomes?</a:t>
-            </a:r>
-          </a:p>
-          <a:p>
-            <a:r>
-              <a:rPr lang="en-US" dirty="0"/>
-              <a:t>GenAI for the wavey illusion</a:t>
-            </a:r>
-          </a:p>
-          <a:p>
-            <a:pPr lvl="1"/>
-            <a:r>
-              <a:rPr lang="en-US" dirty="0"/>
-              <a:t>Success or fail? </a:t>
-            </a:r>
-          </a:p>
-          <a:p>
-            <a:pPr lvl="1"/>
-            <a:r>
-              <a:rPr lang="en-US" dirty="0"/>
-              <a:t>What was your strategy?</a:t>
-            </a:r>
-          </a:p>
-          <a:p>
-            <a:pPr lvl="1"/>
-            <a:r>
-              <a:rPr lang="en-US" dirty="0"/>
-              <a:t>How many iterations? </a:t>
-            </a:r>
-          </a:p>
-          <a:p>
-            <a:pPr lvl="1"/>
-            <a:r>
-              <a:rPr lang="en-US" dirty="0"/>
-              <a:t>How did you debug?</a:t>
-            </a:r>
-          </a:p>
-        </p:txBody>
-      </p:sp>
-      <p:pic>
-        <p:nvPicPr>
-          <p:cNvPr id="4" name="Picture 3">
-            <a:extLst>
-              <a:ext uri="{FF2B5EF4-FFF2-40B4-BE49-F238E27FC236}">
-                <a16:creationId xmlns:a16="http://schemas.microsoft.com/office/drawing/2014/main" id="{A2837BB8-A837-8EEF-024A-DFD986CDABD0}"/>
-              </a:ext>
-            </a:extLst>
-          </p:cNvPr>
-          <p:cNvPicPr>
-            <a:picLocks noChangeAspect="1"/>
-          </p:cNvPicPr>
-          <p:nvPr/>
-        </p:nvPicPr>
-        <p:blipFill>
-          <a:blip r:embed="rId2"/>
-          <a:stretch>
-            <a:fillRect/>
-          </a:stretch>
-        </p:blipFill>
-        <p:spPr>
-          <a:xfrm>
-            <a:off x="6539023" y="1934233"/>
-            <a:ext cx="4179864" cy="4160647"/>
+            <a:off x="8129872" y="0"/>
+            <a:ext cx="4062128" cy="6858000"/>
           </a:xfrm>
           <a:prstGeom prst="rect">
             <a:avLst/>
           </a:prstGeom>
-        </p:spPr>
-      </p:pic>
-      <p:cxnSp>
-        <p:nvCxnSpPr>
-          <p:cNvPr id="9" name="Straight Arrow Connector 8">
-            <a:extLst>
-              <a:ext uri="{FF2B5EF4-FFF2-40B4-BE49-F238E27FC236}">
-                <a16:creationId xmlns:a16="http://schemas.microsoft.com/office/drawing/2014/main" id="{3A6A5758-299D-67A8-6C25-447D48F67590}"/>
-              </a:ext>
-            </a:extLst>
-          </p:cNvPr>
-          <p:cNvCxnSpPr>
-            <a:cxnSpLocks/>
-          </p:cNvCxnSpPr>
-          <p:nvPr/>
-        </p:nvCxnSpPr>
-        <p:spPr>
-          <a:xfrm flipH="1" flipV="1">
-            <a:off x="2225617" y="4699591"/>
-            <a:ext cx="910988" cy="712381"/>
-          </a:xfrm>
-          <a:prstGeom prst="straightConnector1">
-            <a:avLst/>
-          </a:prstGeom>
+          <a:solidFill>
+            <a:schemeClr val="bg2">
+              <a:lumMod val="75000"/>
+            </a:schemeClr>
+          </a:solidFill>
           <a:ln>
-            <a:tailEnd type="triangle"/>
+            <a:noFill/>
           </a:ln>
         </p:spPr>
         <p:style>
-          <a:lnRef idx="1">
-            <a:schemeClr val="accent1"/>
+          <a:lnRef idx="2">
+            <a:schemeClr val="accent1">
+              <a:shade val="50000"/>
+            </a:schemeClr>
           </a:lnRef>
-          <a:fillRef idx="0">
+          <a:fillRef idx="1">
             <a:schemeClr val="accent1"/>
           </a:fillRef>
           <a:effectRef idx="0">
             <a:schemeClr val="accent1"/>
           </a:effectRef>
           <a:fontRef idx="minor">
-            <a:schemeClr val="tx1"/>
+            <a:schemeClr val="lt1"/>
           </a:fontRef>
         </p:style>
-      </p:cxnSp>
-      <p:sp>
-        <p:nvSpPr>
-          <p:cNvPr id="10" name="TextBox 9">
-            <a:extLst>
-              <a:ext uri="{FF2B5EF4-FFF2-40B4-BE49-F238E27FC236}">
-                <a16:creationId xmlns:a16="http://schemas.microsoft.com/office/drawing/2014/main" id="{174BE5D6-E6C6-251D-892D-B3C9F2DD620E}"/>
-              </a:ext>
-            </a:extLst>
-          </p:cNvPr>
-          <p:cNvSpPr txBox="1"/>
-          <p:nvPr/>
+        <p:txBody>
+          <a:bodyPr rtlCol="0" anchor="ctr"/>
+          <a:lstStyle/>
+          <a:p>
+            <a:pPr algn="ctr"/>
+            <a:endParaRPr lang="en-US"/>
+          </a:p>
+        </p:txBody>
+      </p:sp>
+      <p:sp>
+        <p:nvSpPr>
+          <p:cNvPr id="3" name="Subtitle 2">
+            <a:extLst>
+              <a:ext uri="{FF2B5EF4-FFF2-40B4-BE49-F238E27FC236}">
+                <a16:creationId xmlns:a16="http://schemas.microsoft.com/office/drawing/2014/main" id="{C5AB9C7C-BEF1-C07A-6A77-DBDD71480AAD}"/>
+              </a:ext>
+            </a:extLst>
+          </p:cNvPr>
+          <p:cNvSpPr>
+            <a:spLocks noGrp="1"/>
+          </p:cNvSpPr>
+          <p:nvPr>
+            <p:ph type="subTitle" idx="1"/>
+          </p:nvPr>
         </p:nvSpPr>
         <p:spPr>
           <a:xfrm>
-            <a:off x="2317898" y="5411972"/>
-            <a:ext cx="3863365" cy="369332"/>
-          </a:xfrm>
-          <a:prstGeom prst="rect">
-            <a:avLst/>
-          </a:prstGeom>
-          <a:noFill/>
-        </p:spPr>
-        <p:txBody>
-          <a:bodyPr wrap="none" rtlCol="0">
-            <a:spAutoFit/>
+            <a:off x="8533732" y="2173266"/>
+            <a:ext cx="3254408" cy="2511468"/>
+          </a:xfrm>
+        </p:spPr>
+        <p:txBody>
+          <a:bodyPr anchor="ctr">
+            <a:normAutofit/>
           </a:bodyPr>
           <a:lstStyle/>
           <a:p>
             <a:r>
-              <a:rPr lang="en-US" dirty="0"/>
-              <a:t>Find errors/shortcomings and fix them?</a:t>
+              <a:rPr lang="en-US" sz="2400" dirty="0">
+                <a:solidFill>
+                  <a:schemeClr val="tx2">
+                    <a:lumMod val="90000"/>
+                  </a:schemeClr>
+                </a:solidFill>
+              </a:rPr>
+              <a:t>Computer </a:t>
+            </a:r>
+            <a:r>
+              <a:rPr lang="en-US" sz="2400">
+                <a:solidFill>
+                  <a:schemeClr val="tx2">
+                    <a:lumMod val="90000"/>
+                  </a:schemeClr>
+                </a:solidFill>
+              </a:rPr>
+              <a:t>Science I </a:t>
+            </a:r>
+            <a:endParaRPr lang="en-US" sz="2400" dirty="0">
+              <a:solidFill>
+                <a:schemeClr val="tx2">
+                  <a:lumMod val="90000"/>
+                </a:schemeClr>
+              </a:solidFill>
+            </a:endParaRPr>
+          </a:p>
+          <a:p>
+            <a:r>
+              <a:rPr lang="en-US" sz="2400" dirty="0">
+                <a:solidFill>
+                  <a:schemeClr val="tx2">
+                    <a:lumMod val="90000"/>
+                  </a:schemeClr>
+                </a:solidFill>
+              </a:rPr>
+              <a:t>Variables, Literals and Types</a:t>
             </a:r>
           </a:p>
         </p:txBody>
@@ -9351,7 +9244,7 @@
     </p:spTree>
     <p:extLst>
       <p:ext uri="{BB962C8B-B14F-4D97-AF65-F5344CB8AC3E}">
-        <p14:creationId xmlns:p14="http://schemas.microsoft.com/office/powerpoint/2010/main" val="3627727674"/>
+        <p14:creationId xmlns:p14="http://schemas.microsoft.com/office/powerpoint/2010/main" val="3002068836"/>
       </p:ext>
     </p:extLst>
   </p:cSld>
@@ -12421,7 +12314,7 @@
           <p:cNvPr id="2" name="Title 1">
             <a:extLst>
               <a:ext uri="{FF2B5EF4-FFF2-40B4-BE49-F238E27FC236}">
-                <a16:creationId xmlns:a16="http://schemas.microsoft.com/office/drawing/2014/main" id="{BDF1F3C1-2C2F-77D9-EF95-2A1FC3FF0B9F}"/>
+                <a16:creationId xmlns:a16="http://schemas.microsoft.com/office/drawing/2014/main" id="{F44AC4E3-91E1-D318-C9FD-C51C7FA7FDBA}"/>
               </a:ext>
             </a:extLst>
           </p:cNvPr>
@@ -12432,37 +12325,29 @@
             <p:ph type="title"/>
           </p:nvPr>
         </p:nvSpPr>
-        <p:spPr/>
+        <p:spPr>
+          <a:xfrm>
+            <a:off x="2225617" y="413885"/>
+            <a:ext cx="7729728" cy="1188720"/>
+          </a:xfrm>
+        </p:spPr>
         <p:txBody>
           <a:bodyPr/>
           <a:lstStyle/>
           <a:p>
             <a:r>
-              <a:rPr lang="en-CA" dirty="0"/>
-              <a:t>My 1</a:t>
-            </a:r>
-            <a:r>
-              <a:rPr lang="en-CA" baseline="30000" dirty="0"/>
-              <a:t>st</a:t>
-            </a:r>
-            <a:r>
-              <a:rPr lang="en-CA" dirty="0"/>
-              <a:t> </a:t>
-            </a:r>
-            <a:r>
-              <a:rPr lang="en-CA" dirty="0" err="1"/>
-              <a:t>ATTEMPt</a:t>
-            </a:r>
-            <a:endParaRPr lang="en-CA" dirty="0"/>
-          </a:p>
-        </p:txBody>
-      </p:sp>
-      <p:sp>
-        <p:nvSpPr>
-          <p:cNvPr id="4" name="Content Placeholder 3">
-            <a:extLst>
-              <a:ext uri="{FF2B5EF4-FFF2-40B4-BE49-F238E27FC236}">
-                <a16:creationId xmlns:a16="http://schemas.microsoft.com/office/drawing/2014/main" id="{2AAC0547-68BD-8F6C-9B5C-89D882DB3754}"/>
+              <a:rPr lang="en-US" dirty="0"/>
+              <a:t>Try at Home Recap</a:t>
+            </a:r>
+          </a:p>
+        </p:txBody>
+      </p:sp>
+      <p:sp>
+        <p:nvSpPr>
+          <p:cNvPr id="3" name="Content Placeholder 2">
+            <a:extLst>
+              <a:ext uri="{FF2B5EF4-FFF2-40B4-BE49-F238E27FC236}">
+                <a16:creationId xmlns:a16="http://schemas.microsoft.com/office/drawing/2014/main" id="{E35AAE5B-1BEF-5BC6-978A-C5FB4386EA1F}"/>
               </a:ext>
             </a:extLst>
           </p:cNvPr>
@@ -12470,87 +12355,79 @@
             <a:spLocks noGrp="1"/>
           </p:cNvSpPr>
           <p:nvPr>
-            <p:ph sz="half" idx="1"/>
+            <p:ph idx="1"/>
           </p:nvPr>
         </p:nvSpPr>
-        <p:spPr/>
-        <p:txBody>
-          <a:bodyPr>
-            <a:normAutofit fontScale="70000" lnSpcReduction="20000"/>
-          </a:bodyPr>
-          <a:lstStyle/>
-          <a:p>
-            <a:r>
-              <a:rPr lang="en-US" dirty="0"/>
-              <a:t>Prompt: </a:t>
+        <p:spPr>
+          <a:xfrm>
+            <a:off x="178514" y="2046514"/>
+            <a:ext cx="7729728" cy="2745743"/>
+          </a:xfrm>
+        </p:spPr>
+        <p:txBody>
+          <a:bodyPr/>
+          <a:lstStyle/>
+          <a:p>
+            <a:r>
+              <a:rPr lang="en-US" dirty="0"/>
+              <a:t>Turtle Draw – initial in name</a:t>
+            </a:r>
+          </a:p>
+          <a:p>
+            <a:r>
+              <a:rPr lang="en-US" dirty="0"/>
+              <a:t>Tinkering with the prior code – any interesting outcomes?</a:t>
+            </a:r>
+          </a:p>
+          <a:p>
+            <a:r>
+              <a:rPr lang="en-US" dirty="0"/>
+              <a:t>GenAI for the wavey illusion</a:t>
             </a:r>
           </a:p>
           <a:p>
             <a:pPr lvl="1"/>
             <a:r>
-              <a:rPr lang="en-US" dirty="0">
-                <a:solidFill>
-                  <a:srgbClr val="0070C0"/>
-                </a:solidFill>
-              </a:rPr>
-              <a:t>I want you to generate the code for an optical illusion. The illusion is a wavy grid of boxes alternating with a light green and a dark green. There are 17 small squares along both sides of the square grid. At each intersection between the squares is a small cross along the gridlines with the cross extending about 1/6th across the line into the square. The crosses are either pink or white. the first intersection of grid lines has a white cross. Then there is two pink crosses. Then a single white cross. then a single pink cross. Then there are two white crosses. then a pink cross. then a white cross. Then two pink crosses. and then that pattern repeats until you are at the end of the intersection points with a pink cross. On the second line there is a Pink, white, 2 pink, white, pink, two white and so on. This pattern then repeats.</a:t>
-            </a:r>
-            <a:r>
-              <a:rPr lang="en-US" dirty="0"/>
-              <a:t> </a:t>
-            </a:r>
-            <a:r>
-              <a:rPr lang="en-US" dirty="0">
-                <a:solidFill>
-                  <a:srgbClr val="FF0000"/>
-                </a:solidFill>
-              </a:rPr>
-              <a:t>Please generate the picture for me, and then python code to generate it.</a:t>
-            </a:r>
-          </a:p>
-          <a:p>
-            <a:r>
-              <a:rPr lang="en-CA" dirty="0">
-                <a:solidFill>
-                  <a:schemeClr val="tx1"/>
-                </a:solidFill>
-              </a:rPr>
-              <a:t>Blue is the </a:t>
-            </a:r>
-            <a:r>
-              <a:rPr lang="en-CA" i="1" dirty="0">
-                <a:solidFill>
-                  <a:schemeClr val="tx1"/>
-                </a:solidFill>
-              </a:rPr>
-              <a:t>context</a:t>
-            </a:r>
-            <a:r>
-              <a:rPr lang="en-CA" dirty="0">
-                <a:solidFill>
-                  <a:schemeClr val="tx1"/>
-                </a:solidFill>
-              </a:rPr>
-              <a:t> provided to the AI, while the red is the task I am giving it to do.</a:t>
+              <a:rPr lang="en-US" dirty="0"/>
+              <a:t>Success or fail? </a:t>
+            </a:r>
+          </a:p>
+          <a:p>
+            <a:pPr lvl="1"/>
+            <a:r>
+              <a:rPr lang="en-US" dirty="0"/>
+              <a:t>What was your strategy?</a:t>
+            </a:r>
+          </a:p>
+          <a:p>
+            <a:pPr lvl="1"/>
+            <a:r>
+              <a:rPr lang="en-US" dirty="0"/>
+              <a:t>How many iterations? </a:t>
+            </a:r>
+          </a:p>
+          <a:p>
+            <a:pPr lvl="1"/>
+            <a:r>
+              <a:rPr lang="en-US" dirty="0"/>
+              <a:t>How did you debug?</a:t>
             </a:r>
           </a:p>
         </p:txBody>
       </p:sp>
       <p:pic>
         <p:nvPicPr>
-          <p:cNvPr id="7" name="Content Placeholder 6">
-            <a:extLst>
-              <a:ext uri="{FF2B5EF4-FFF2-40B4-BE49-F238E27FC236}">
-                <a16:creationId xmlns:a16="http://schemas.microsoft.com/office/drawing/2014/main" id="{4425E9BD-6D44-1756-87B4-1DB24A52892F}"/>
+          <p:cNvPr id="4" name="Picture 3">
+            <a:extLst>
+              <a:ext uri="{FF2B5EF4-FFF2-40B4-BE49-F238E27FC236}">
+                <a16:creationId xmlns:a16="http://schemas.microsoft.com/office/drawing/2014/main" id="{A2837BB8-A837-8EEF-024A-DFD986CDABD0}"/>
               </a:ext>
             </a:extLst>
           </p:cNvPr>
           <p:cNvPicPr>
-            <a:picLocks noGrp="1" noChangeAspect="1"/>
+            <a:picLocks noChangeAspect="1"/>
           </p:cNvPicPr>
-          <p:nvPr>
-            <p:ph sz="half" idx="2"/>
-          </p:nvPr>
+          <p:nvPr/>
         </p:nvPicPr>
         <p:blipFill>
           <a:blip r:embed="rId2"/>
@@ -12560,18 +12437,94 @@
         </p:blipFill>
         <p:spPr>
           <a:xfrm>
-            <a:off x="6096000" y="2336292"/>
-            <a:ext cx="4271771" cy="4271771"/>
+            <a:off x="6539023" y="1934233"/>
+            <a:ext cx="4179864" cy="4160647"/>
           </a:xfrm>
           <a:prstGeom prst="rect">
             <a:avLst/>
           </a:prstGeom>
         </p:spPr>
       </p:pic>
+      <p:cxnSp>
+        <p:nvCxnSpPr>
+          <p:cNvPr id="9" name="Straight Arrow Connector 8">
+            <a:extLst>
+              <a:ext uri="{FF2B5EF4-FFF2-40B4-BE49-F238E27FC236}">
+                <a16:creationId xmlns:a16="http://schemas.microsoft.com/office/drawing/2014/main" id="{3A6A5758-299D-67A8-6C25-447D48F67590}"/>
+              </a:ext>
+            </a:extLst>
+          </p:cNvPr>
+          <p:cNvCxnSpPr>
+            <a:cxnSpLocks/>
+          </p:cNvCxnSpPr>
+          <p:nvPr/>
+        </p:nvCxnSpPr>
+        <p:spPr>
+          <a:xfrm flipH="1" flipV="1">
+            <a:off x="2225617" y="4699591"/>
+            <a:ext cx="910988" cy="712381"/>
+          </a:xfrm>
+          <a:prstGeom prst="straightConnector1">
+            <a:avLst/>
+          </a:prstGeom>
+          <a:ln>
+            <a:tailEnd type="triangle"/>
+          </a:ln>
+        </p:spPr>
+        <p:style>
+          <a:lnRef idx="1">
+            <a:schemeClr val="accent1"/>
+          </a:lnRef>
+          <a:fillRef idx="0">
+            <a:schemeClr val="accent1"/>
+          </a:fillRef>
+          <a:effectRef idx="0">
+            <a:schemeClr val="accent1"/>
+          </a:effectRef>
+          <a:fontRef idx="minor">
+            <a:schemeClr val="tx1"/>
+          </a:fontRef>
+        </p:style>
+      </p:cxnSp>
+      <p:sp>
+        <p:nvSpPr>
+          <p:cNvPr id="10" name="TextBox 9">
+            <a:extLst>
+              <a:ext uri="{FF2B5EF4-FFF2-40B4-BE49-F238E27FC236}">
+                <a16:creationId xmlns:a16="http://schemas.microsoft.com/office/drawing/2014/main" id="{174BE5D6-E6C6-251D-892D-B3C9F2DD620E}"/>
+              </a:ext>
+            </a:extLst>
+          </p:cNvPr>
+          <p:cNvSpPr txBox="1"/>
+          <p:nvPr/>
+        </p:nvSpPr>
+        <p:spPr>
+          <a:xfrm>
+            <a:off x="2317898" y="5411972"/>
+            <a:ext cx="3863365" cy="369332"/>
+          </a:xfrm>
+          <a:prstGeom prst="rect">
+            <a:avLst/>
+          </a:prstGeom>
+          <a:noFill/>
+        </p:spPr>
+        <p:txBody>
+          <a:bodyPr wrap="none" rtlCol="0">
+            <a:spAutoFit/>
+          </a:bodyPr>
+          <a:lstStyle/>
+          <a:p>
+            <a:r>
+              <a:rPr lang="en-US" dirty="0"/>
+              <a:t>Find errors/shortcomings and fix them?</a:t>
+            </a:r>
+          </a:p>
+        </p:txBody>
+      </p:sp>
     </p:spTree>
     <p:extLst>
       <p:ext uri="{BB962C8B-B14F-4D97-AF65-F5344CB8AC3E}">
-        <p14:creationId xmlns:p14="http://schemas.microsoft.com/office/powerpoint/2010/main" val="1670994567"/>
+        <p14:creationId xmlns:p14="http://schemas.microsoft.com/office/powerpoint/2010/main" val="3627727674"/>
       </p:ext>
     </p:extLst>
   </p:cSld>
@@ -14460,6 +14413,193 @@
   <p:cSld>
     <p:spTree>
       <p:nvGrpSpPr>
+        <p:cNvPr id="1" name=""/>
+        <p:cNvGrpSpPr/>
+        <p:nvPr/>
+      </p:nvGrpSpPr>
+      <p:grpSpPr>
+        <a:xfrm>
+          <a:off x="0" y="0"/>
+          <a:ext cx="0" cy="0"/>
+          <a:chOff x="0" y="0"/>
+          <a:chExt cx="0" cy="0"/>
+        </a:xfrm>
+      </p:grpSpPr>
+      <p:sp>
+        <p:nvSpPr>
+          <p:cNvPr id="2" name="Title 1">
+            <a:extLst>
+              <a:ext uri="{FF2B5EF4-FFF2-40B4-BE49-F238E27FC236}">
+                <a16:creationId xmlns:a16="http://schemas.microsoft.com/office/drawing/2014/main" id="{BDF1F3C1-2C2F-77D9-EF95-2A1FC3FF0B9F}"/>
+              </a:ext>
+            </a:extLst>
+          </p:cNvPr>
+          <p:cNvSpPr>
+            <a:spLocks noGrp="1"/>
+          </p:cNvSpPr>
+          <p:nvPr>
+            <p:ph type="title"/>
+          </p:nvPr>
+        </p:nvSpPr>
+        <p:spPr/>
+        <p:txBody>
+          <a:bodyPr/>
+          <a:lstStyle/>
+          <a:p>
+            <a:r>
+              <a:rPr lang="en-CA" dirty="0"/>
+              <a:t>My 1</a:t>
+            </a:r>
+            <a:r>
+              <a:rPr lang="en-CA" baseline="30000" dirty="0"/>
+              <a:t>st</a:t>
+            </a:r>
+            <a:r>
+              <a:rPr lang="en-CA" dirty="0"/>
+              <a:t> </a:t>
+            </a:r>
+            <a:r>
+              <a:rPr lang="en-CA" dirty="0" err="1"/>
+              <a:t>ATTEMPt</a:t>
+            </a:r>
+            <a:endParaRPr lang="en-CA" dirty="0"/>
+          </a:p>
+        </p:txBody>
+      </p:sp>
+      <p:sp>
+        <p:nvSpPr>
+          <p:cNvPr id="4" name="Content Placeholder 3">
+            <a:extLst>
+              <a:ext uri="{FF2B5EF4-FFF2-40B4-BE49-F238E27FC236}">
+                <a16:creationId xmlns:a16="http://schemas.microsoft.com/office/drawing/2014/main" id="{2AAC0547-68BD-8F6C-9B5C-89D882DB3754}"/>
+              </a:ext>
+            </a:extLst>
+          </p:cNvPr>
+          <p:cNvSpPr>
+            <a:spLocks noGrp="1"/>
+          </p:cNvSpPr>
+          <p:nvPr>
+            <p:ph sz="half" idx="1"/>
+          </p:nvPr>
+        </p:nvSpPr>
+        <p:spPr>
+          <a:xfrm>
+            <a:off x="440267" y="2487167"/>
+            <a:ext cx="5433513" cy="3970020"/>
+          </a:xfrm>
+        </p:spPr>
+        <p:txBody>
+          <a:bodyPr>
+            <a:normAutofit fontScale="92500" lnSpcReduction="20000"/>
+          </a:bodyPr>
+          <a:lstStyle/>
+          <a:p>
+            <a:r>
+              <a:rPr lang="en-US" dirty="0"/>
+              <a:t>Prompt: </a:t>
+            </a:r>
+          </a:p>
+          <a:p>
+            <a:pPr lvl="1"/>
+            <a:r>
+              <a:rPr lang="en-US" dirty="0">
+                <a:solidFill>
+                  <a:srgbClr val="0070C0"/>
+                </a:solidFill>
+              </a:rPr>
+              <a:t>I want you to generate the code for an optical illusion. The illusion is a wavy grid of boxes alternating with a light green and a dark green. There are 17 small squares along both sides of the square grid. At each intersection between the squares is a small cross along the gridlines with the cross extending about 1/6th across the line into the square. The crosses are either pink or white. the first intersection of grid lines has a white cross. Then there is two pink crosses. Then a single white cross. then a single pink cross. Then there are two white crosses. then a pink cross. then a white cross. Then two pink crosses. and then that pattern repeats until you are at the end of the intersection points with a pink cross. On the second line there is a Pink, white, 2 pink, white, pink, two white and so on. This pattern then repeats.</a:t>
+            </a:r>
+            <a:r>
+              <a:rPr lang="en-US" dirty="0"/>
+              <a:t> </a:t>
+            </a:r>
+            <a:r>
+              <a:rPr lang="en-US" dirty="0">
+                <a:solidFill>
+                  <a:srgbClr val="FF0000"/>
+                </a:solidFill>
+              </a:rPr>
+              <a:t>Please generate the picture for me, and then python code to generate it.</a:t>
+            </a:r>
+          </a:p>
+          <a:p>
+            <a:r>
+              <a:rPr lang="en-CA" dirty="0">
+                <a:solidFill>
+                  <a:schemeClr val="tx1"/>
+                </a:solidFill>
+              </a:rPr>
+              <a:t>Blue is the </a:t>
+            </a:r>
+            <a:r>
+              <a:rPr lang="en-CA" i="1" dirty="0">
+                <a:solidFill>
+                  <a:schemeClr val="tx1"/>
+                </a:solidFill>
+              </a:rPr>
+              <a:t>context</a:t>
+            </a:r>
+            <a:r>
+              <a:rPr lang="en-CA" dirty="0">
+                <a:solidFill>
+                  <a:schemeClr val="tx1"/>
+                </a:solidFill>
+              </a:rPr>
+              <a:t> provided to the AI, while the red is the task I am giving it to do.</a:t>
+            </a:r>
+          </a:p>
+        </p:txBody>
+      </p:sp>
+      <p:pic>
+        <p:nvPicPr>
+          <p:cNvPr id="7" name="Content Placeholder 6">
+            <a:extLst>
+              <a:ext uri="{FF2B5EF4-FFF2-40B4-BE49-F238E27FC236}">
+                <a16:creationId xmlns:a16="http://schemas.microsoft.com/office/drawing/2014/main" id="{4425E9BD-6D44-1756-87B4-1DB24A52892F}"/>
+              </a:ext>
+            </a:extLst>
+          </p:cNvPr>
+          <p:cNvPicPr>
+            <a:picLocks noGrp="1" noChangeAspect="1"/>
+          </p:cNvPicPr>
+          <p:nvPr>
+            <p:ph sz="half" idx="2"/>
+          </p:nvPr>
+        </p:nvPicPr>
+        <p:blipFill>
+          <a:blip r:embed="rId2"/>
+          <a:stretch>
+            <a:fillRect/>
+          </a:stretch>
+        </p:blipFill>
+        <p:spPr>
+          <a:xfrm>
+            <a:off x="6096000" y="2336292"/>
+            <a:ext cx="4271771" cy="4271771"/>
+          </a:xfrm>
+          <a:prstGeom prst="rect">
+            <a:avLst/>
+          </a:prstGeom>
+        </p:spPr>
+      </p:pic>
+    </p:spTree>
+    <p:extLst>
+      <p:ext uri="{BB962C8B-B14F-4D97-AF65-F5344CB8AC3E}">
+        <p14:creationId xmlns:p14="http://schemas.microsoft.com/office/powerpoint/2010/main" val="1670994567"/>
+      </p:ext>
+    </p:extLst>
+  </p:cSld>
+  <p:clrMapOvr>
+    <a:masterClrMapping/>
+  </p:clrMapOvr>
+</p:sld>
+</file>
+
+<file path=ppt/slides/slide5.xml><?xml version="1.0" encoding="utf-8"?>
+<p:sld xmlns:a="http://schemas.openxmlformats.org/drawingml/2006/main" xmlns:r="http://schemas.openxmlformats.org/officeDocument/2006/relationships" xmlns:p="http://schemas.openxmlformats.org/presentationml/2006/main">
+  <p:cSld>
+    <p:spTree>
+      <p:nvGrpSpPr>
         <p:cNvPr id="1" name="">
           <a:extLst>
             <a:ext uri="{FF2B5EF4-FFF2-40B4-BE49-F238E27FC236}">
@@ -14537,18 +14677,18 @@
         </p:nvSpPr>
         <p:spPr>
           <a:xfrm>
-            <a:off x="1581913" y="2638044"/>
-            <a:ext cx="4270246" cy="3707892"/>
+            <a:off x="1072444" y="2638043"/>
+            <a:ext cx="5265870" cy="3874005"/>
           </a:xfrm>
         </p:spPr>
         <p:txBody>
           <a:bodyPr>
-            <a:normAutofit fontScale="62500" lnSpcReduction="20000"/>
+            <a:normAutofit/>
           </a:bodyPr>
           <a:lstStyle/>
           <a:p>
             <a:r>
-              <a:rPr lang="en-US" dirty="0"/>
+              <a:rPr lang="en-US" sz="1200" dirty="0"/>
               <a:t>Prompt: </a:t>
             </a:r>
           </a:p>
@@ -14557,7 +14697,7 @@
               <a:buNone/>
             </a:pPr>
             <a:r>
-              <a:rPr lang="en-US" dirty="0">
+              <a:rPr lang="en-US" sz="1100" dirty="0">
                 <a:solidFill>
                   <a:srgbClr val="7030A0"/>
                 </a:solidFill>
@@ -14565,7 +14705,7 @@
               <a:t>Some of your crosses are not at the intersections of the gridlines, but are instead in the middle of the lines. Make sure that the </a:t>
             </a:r>
             <a:r>
-              <a:rPr lang="en-US" dirty="0" err="1">
+              <a:rPr lang="en-US" sz="1100" dirty="0" err="1">
                 <a:solidFill>
                   <a:srgbClr val="7030A0"/>
                 </a:solidFill>
@@ -14573,7 +14713,7 @@
               <a:t>centre</a:t>
             </a:r>
             <a:r>
-              <a:rPr lang="en-US" dirty="0">
+              <a:rPr lang="en-US" sz="1100" dirty="0">
                 <a:solidFill>
                   <a:srgbClr val="7030A0"/>
                 </a:solidFill>
@@ -14581,11 +14721,11 @@
               <a:t> of the cross is at the intersection, with the perpendicular pieces of the cross going exactly along the gridlines.</a:t>
             </a:r>
             <a:r>
-              <a:rPr lang="en-US" dirty="0"/>
+              <a:rPr lang="en-US" sz="1100" dirty="0"/>
               <a:t> </a:t>
             </a:r>
             <a:r>
-              <a:rPr lang="en-US" dirty="0">
+              <a:rPr lang="en-US" sz="1100" dirty="0">
                 <a:solidFill>
                   <a:srgbClr val="0070C0"/>
                 </a:solidFill>
@@ -14593,7 +14733,7 @@
               <a:t>I want you to generate the code for an optical illusion. The illusion is a wavy grid of boxes alternating with a light green and a dark green. There are 17 small squares along both sides of the square grid. At each intersection between the squares is a small cross along the gridlines with the cross extending about 1/6th across the line into the square. The crosses are either pink or white. the first intersection of grid lines has a white cross. Then there is two pink crosses. Then a single white cross. then a single pink cross. Then there are two white crosses. then a pink cross. then a white cross. Then two pink crosses. and then that pattern repeats until you are at the end of the intersection points with a pink cross. On the second line there is a Pink, white, 2 pink, white, pink, two white and so on. This pattern then repeats. </a:t>
             </a:r>
             <a:r>
-              <a:rPr lang="en-US" dirty="0">
+              <a:rPr lang="en-US" sz="1100" dirty="0">
                 <a:solidFill>
                   <a:srgbClr val="FF0000"/>
                 </a:solidFill>
@@ -14601,15 +14741,15 @@
               <a:t>Please generate the picture for me, and then python code to generate it.</a:t>
             </a:r>
             <a:r>
-              <a:rPr lang="en-US" dirty="0"/>
+              <a:rPr lang="en-US" sz="1100" dirty="0"/>
               <a:t> </a:t>
             </a:r>
             <a:r>
-              <a:rPr lang="en-US" b="1" dirty="0"/>
+              <a:rPr lang="en-US" sz="1100" b="1" dirty="0"/>
               <a:t>Check to make sure that all of the crosses are actually on the intersections of the gridlines. </a:t>
             </a:r>
             <a:r>
-              <a:rPr lang="en-CA" b="1" dirty="0">
+              <a:rPr lang="en-CA" sz="1100" b="1" dirty="0">
                 <a:solidFill>
                   <a:schemeClr val="tx1"/>
                 </a:solidFill>
@@ -14617,7 +14757,7 @@
               <a:t>Blue is the </a:t>
             </a:r>
             <a:r>
-              <a:rPr lang="en-CA" b="1" i="1" dirty="0">
+              <a:rPr lang="en-CA" sz="1100" b="1" i="1" dirty="0">
                 <a:solidFill>
                   <a:schemeClr val="tx1"/>
                 </a:solidFill>
@@ -14625,7 +14765,7 @@
               <a:t>context</a:t>
             </a:r>
             <a:r>
-              <a:rPr lang="en-CA" b="1" dirty="0">
+              <a:rPr lang="en-CA" sz="1100" b="1" dirty="0">
                 <a:solidFill>
                   <a:schemeClr val="tx1"/>
                 </a:solidFill>
@@ -14635,7 +14775,7 @@
           </a:p>
           <a:p>
             <a:r>
-              <a:rPr lang="en-CA" dirty="0">
+              <a:rPr lang="en-CA" sz="1200" dirty="0">
                 <a:solidFill>
                   <a:schemeClr val="tx1"/>
                 </a:solidFill>
@@ -14643,7 +14783,7 @@
               <a:t>Purple is feedback based on the first attempt.  That will add it to the </a:t>
             </a:r>
             <a:r>
-              <a:rPr lang="en-CA" i="1" dirty="0">
+              <a:rPr lang="en-CA" sz="1200" i="1" dirty="0">
                 <a:solidFill>
                   <a:schemeClr val="tx1"/>
                 </a:solidFill>
@@ -14651,7 +14791,7 @@
               <a:t>context</a:t>
             </a:r>
             <a:r>
-              <a:rPr lang="en-CA" dirty="0">
+              <a:rPr lang="en-CA" sz="1200" dirty="0">
                 <a:solidFill>
                   <a:schemeClr val="tx1"/>
                 </a:solidFill>
@@ -14680,7 +14820,7 @@
         <p:spPr/>
         <p:txBody>
           <a:bodyPr>
-            <a:normAutofit fontScale="62500" lnSpcReduction="20000"/>
+            <a:normAutofit/>
           </a:bodyPr>
           <a:lstStyle/>
           <a:p>
@@ -14739,121 +14879,6 @@
     <p:extLst>
       <p:ext uri="{BB962C8B-B14F-4D97-AF65-F5344CB8AC3E}">
         <p14:creationId xmlns:p14="http://schemas.microsoft.com/office/powerpoint/2010/main" val="211227348"/>
-      </p:ext>
-    </p:extLst>
-  </p:cSld>
-  <p:clrMapOvr>
-    <a:masterClrMapping/>
-  </p:clrMapOvr>
-</p:sld>
-</file>
-
-<file path=ppt/slides/slide5.xml><?xml version="1.0" encoding="utf-8"?>
-<p:sld xmlns:a="http://schemas.openxmlformats.org/drawingml/2006/main" xmlns:r="http://schemas.openxmlformats.org/officeDocument/2006/relationships" xmlns:p="http://schemas.openxmlformats.org/presentationml/2006/main">
-  <p:cSld>
-    <p:spTree>
-      <p:nvGrpSpPr>
-        <p:cNvPr id="1" name=""/>
-        <p:cNvGrpSpPr/>
-        <p:nvPr/>
-      </p:nvGrpSpPr>
-      <p:grpSpPr>
-        <a:xfrm>
-          <a:off x="0" y="0"/>
-          <a:ext cx="0" cy="0"/>
-          <a:chOff x="0" y="0"/>
-          <a:chExt cx="0" cy="0"/>
-        </a:xfrm>
-      </p:grpSpPr>
-      <p:sp>
-        <p:nvSpPr>
-          <p:cNvPr id="2" name="Title 1">
-            <a:extLst>
-              <a:ext uri="{FF2B5EF4-FFF2-40B4-BE49-F238E27FC236}">
-                <a16:creationId xmlns:a16="http://schemas.microsoft.com/office/drawing/2014/main" id="{060D6624-FC1D-31D3-7171-2D0BD15D3A5B}"/>
-              </a:ext>
-            </a:extLst>
-          </p:cNvPr>
-          <p:cNvSpPr>
-            <a:spLocks noGrp="1"/>
-          </p:cNvSpPr>
-          <p:nvPr>
-            <p:ph type="title"/>
-          </p:nvPr>
-        </p:nvSpPr>
-        <p:spPr/>
-        <p:txBody>
-          <a:bodyPr/>
-          <a:lstStyle/>
-          <a:p>
-            <a:r>
-              <a:rPr lang="en-US" dirty="0"/>
-              <a:t>Code Examples</a:t>
-            </a:r>
-          </a:p>
-        </p:txBody>
-      </p:sp>
-      <p:sp>
-        <p:nvSpPr>
-          <p:cNvPr id="3" name="Content Placeholder 2">
-            <a:extLst>
-              <a:ext uri="{FF2B5EF4-FFF2-40B4-BE49-F238E27FC236}">
-                <a16:creationId xmlns:a16="http://schemas.microsoft.com/office/drawing/2014/main" id="{7B5D4780-4F82-B5DC-3DB7-DDE5E6CFC579}"/>
-              </a:ext>
-            </a:extLst>
-          </p:cNvPr>
-          <p:cNvSpPr>
-            <a:spLocks noGrp="1"/>
-          </p:cNvSpPr>
-          <p:nvPr>
-            <p:ph idx="1"/>
-          </p:nvPr>
-        </p:nvSpPr>
-        <p:spPr/>
-        <p:txBody>
-          <a:bodyPr/>
-          <a:lstStyle/>
-          <a:p>
-            <a:pPr marL="0" indent="0">
-              <a:buNone/>
-            </a:pPr>
-            <a:r>
-              <a:rPr lang="en-US" dirty="0"/>
-              <a:t>Today’s code examples are found here:</a:t>
-            </a:r>
-          </a:p>
-          <a:p>
-            <a:pPr marL="0" indent="0">
-              <a:buNone/>
-            </a:pPr>
-            <a:r>
-              <a:rPr lang="en-US" dirty="0">
-                <a:hlinkClick r:id="rId2"/>
-              </a:rPr>
-              <a:t>https://colab.research.google.com/github/cdspower-upei/2026W-CS1910-Students/blob/main/Lectures/L03/L03-Examples.ipynb</a:t>
-            </a:r>
-            <a:endParaRPr lang="en-US" dirty="0"/>
-          </a:p>
-          <a:p>
-            <a:pPr marL="0" indent="0">
-              <a:buNone/>
-            </a:pPr>
-            <a:endParaRPr lang="en-US" dirty="0"/>
-          </a:p>
-          <a:p>
-            <a:pPr marL="0" indent="0">
-              <a:buNone/>
-            </a:pPr>
-            <a:endParaRPr lang="en-US" dirty="0">
-              <a:hlinkClick r:id="rId3"/>
-            </a:endParaRPr>
-          </a:p>
-        </p:txBody>
-      </p:sp>
-    </p:spTree>
-    <p:extLst>
-      <p:ext uri="{BB962C8B-B14F-4D97-AF65-F5344CB8AC3E}">
-        <p14:creationId xmlns:p14="http://schemas.microsoft.com/office/powerpoint/2010/main" val="2938145428"/>
       </p:ext>
     </p:extLst>
   </p:cSld>

</xml_diff>

<commit_message>
Updaated with Everygreen links.
</commit_message>
<xml_diff>
--- a/lectures/03-Variables-Literals-Types/CS1910_Variables-Literals-Types_Lecture.pptx
+++ b/lectures/03-Variables-Literals-Types/CS1910_Variables-Literals-Types_Lecture.pptx
@@ -5,7 +5,7 @@
     <p:sldMasterId id="2147483696" r:id="rId1"/>
   </p:sldMasterIdLst>
   <p:notesMasterIdLst>
-    <p:notesMasterId r:id="rId38"/>
+    <p:notesMasterId r:id="rId37"/>
   </p:notesMasterIdLst>
   <p:sldIdLst>
     <p:sldId id="346" r:id="rId2"/>
@@ -43,7 +43,6 @@
     <p:sldId id="296" r:id="rId34"/>
     <p:sldId id="339" r:id="rId35"/>
     <p:sldId id="299" r:id="rId36"/>
-    <p:sldId id="341" r:id="rId37"/>
   </p:sldIdLst>
   <p:sldSz cx="12192000" cy="6858000"/>
   <p:notesSz cx="6858000" cy="9144000"/>
@@ -150,6 +149,14 @@
 </p:presentation>
 </file>
 
+<file path=ppt/revisionInfo.xml><?xml version="1.0" encoding="utf-8"?>
+<p1510:revInfo xmlns:a="http://schemas.openxmlformats.org/drawingml/2006/main" xmlns:r="http://schemas.openxmlformats.org/officeDocument/2006/relationships" xmlns:p1510="http://schemas.microsoft.com/office/powerpoint/2015/10/main">
+  <p1510:revLst>
+    <p1510:client id="{FAC14A51-553F-B74B-BB81-4749CE0B1C2E}" v="6" dt="2026-09-15T00:51:31.680"/>
+  </p1510:revLst>
+</p1510:revInfo>
+</file>
+
 <file path=ppt/changesInfos/changesInfo1.xml><?xml version="1.0" encoding="utf-8"?>
 <pc:chgInfo xmlns:a="http://schemas.openxmlformats.org/drawingml/2006/main" xmlns:r="http://schemas.openxmlformats.org/officeDocument/2006/relationships" xmlns:ac="http://schemas.microsoft.com/office/drawing/2013/main/command" xmlns:pc="http://schemas.microsoft.com/office/powerpoint/2013/main/command">
   <pc:docChgLst>
@@ -159,13 +166,6 @@
       <pc:docMkLst>
         <pc:docMk/>
       </pc:docMkLst>
-      <pc:sldChg chg="del">
-        <pc:chgData name="Christopher Power" userId="83706efc-52ec-4aad-b93a-e27c6e901a30" providerId="ADAL" clId="{020B0DAE-24A7-40F8-9A5C-565589CDAAC4}" dt="2026-09-03T19:35:11.671" v="17" actId="47"/>
-        <pc:sldMkLst>
-          <pc:docMk/>
-          <pc:sldMk cId="2938145428" sldId="340"/>
-        </pc:sldMkLst>
-      </pc:sldChg>
       <pc:sldChg chg="modSp mod">
         <pc:chgData name="Christopher Power" userId="83706efc-52ec-4aad-b93a-e27c6e901a30" providerId="ADAL" clId="{020B0DAE-24A7-40F8-9A5C-565589CDAAC4}" dt="2026-09-03T19:34:07.854" v="16" actId="27636"/>
         <pc:sldMkLst>
@@ -210,22 +210,6 @@
           <pc:docMk/>
           <pc:sldMk cId="1441734341" sldId="346"/>
         </pc:sldMkLst>
-        <pc:spChg chg="del mod ord">
-          <ac:chgData name="Christopher Power" userId="83706efc-52ec-4aad-b93a-e27c6e901a30" providerId="ADAL" clId="{020B0DAE-24A7-40F8-9A5C-565589CDAAC4}" dt="2026-09-03T19:35:24.537" v="19" actId="700"/>
-          <ac:spMkLst>
-            <pc:docMk/>
-            <pc:sldMk cId="1441734341" sldId="346"/>
-            <ac:spMk id="2" creationId="{84FE4F11-01F6-1AE2-D19B-F3A6B0DCDE28}"/>
-          </ac:spMkLst>
-        </pc:spChg>
-        <pc:spChg chg="del mod ord">
-          <ac:chgData name="Christopher Power" userId="83706efc-52ec-4aad-b93a-e27c6e901a30" providerId="ADAL" clId="{020B0DAE-24A7-40F8-9A5C-565589CDAAC4}" dt="2026-09-03T19:35:24.537" v="19" actId="700"/>
-          <ac:spMkLst>
-            <pc:docMk/>
-            <pc:sldMk cId="1441734341" sldId="346"/>
-            <ac:spMk id="3" creationId="{08572B9A-2E18-0F61-02C8-A2B3C27A99C4}"/>
-          </ac:spMkLst>
-        </pc:spChg>
         <pc:spChg chg="add mod ord">
           <ac:chgData name="Christopher Power" userId="83706efc-52ec-4aad-b93a-e27c6e901a30" providerId="ADAL" clId="{020B0DAE-24A7-40F8-9A5C-565589CDAAC4}" dt="2026-09-03T19:35:24.537" v="19" actId="700"/>
           <ac:spMkLst>
@@ -242,6 +226,68 @@
             <ac:spMk id="5" creationId="{7EAEFB34-A5B5-F874-5D40-3B13BCF10EF9}"/>
           </ac:spMkLst>
         </pc:spChg>
+      </pc:sldChg>
+    </pc:docChg>
+  </pc:docChgLst>
+  <pc:docChgLst>
+    <pc:chgData name="Christopher Power" userId="83706efc-52ec-4aad-b93a-e27c6e901a30" providerId="ADAL" clId="{334A65D2-812A-5EDD-A5B2-F31A17A4407D}"/>
+    <pc:docChg chg="delSld modSld">
+      <pc:chgData name="Christopher Power" userId="83706efc-52ec-4aad-b93a-e27c6e901a30" providerId="ADAL" clId="{334A65D2-812A-5EDD-A5B2-F31A17A4407D}" dt="2026-09-15T00:53:25.753" v="31" actId="2696"/>
+      <pc:docMkLst>
+        <pc:docMk/>
+      </pc:docMkLst>
+      <pc:sldChg chg="modSp mod">
+        <pc:chgData name="Christopher Power" userId="83706efc-52ec-4aad-b93a-e27c6e901a30" providerId="ADAL" clId="{334A65D2-812A-5EDD-A5B2-F31A17A4407D}" dt="2026-09-15T00:52:02.666" v="30" actId="14"/>
+        <pc:sldMkLst>
+          <pc:docMk/>
+          <pc:sldMk cId="3920957498" sldId="339"/>
+        </pc:sldMkLst>
+        <pc:spChg chg="mod">
+          <ac:chgData name="Christopher Power" userId="83706efc-52ec-4aad-b93a-e27c6e901a30" providerId="ADAL" clId="{334A65D2-812A-5EDD-A5B2-F31A17A4407D}" dt="2026-09-15T00:52:02.666" v="30" actId="14"/>
+          <ac:spMkLst>
+            <pc:docMk/>
+            <pc:sldMk cId="3920957498" sldId="339"/>
+            <ac:spMk id="3" creationId="{2BD62736-1AA5-C630-D2A2-67E113519C36}"/>
+          </ac:spMkLst>
+        </pc:spChg>
+      </pc:sldChg>
+      <pc:sldChg chg="del">
+        <pc:chgData name="Christopher Power" userId="83706efc-52ec-4aad-b93a-e27c6e901a30" providerId="ADAL" clId="{334A65D2-812A-5EDD-A5B2-F31A17A4407D}" dt="2026-09-15T00:53:25.753" v="31" actId="2696"/>
+        <pc:sldMkLst>
+          <pc:docMk/>
+          <pc:sldMk cId="2027712955" sldId="341"/>
+        </pc:sldMkLst>
+      </pc:sldChg>
+      <pc:sldChg chg="addSp delSp modSp mod">
+        <pc:chgData name="Christopher Power" userId="83706efc-52ec-4aad-b93a-e27c6e901a30" providerId="ADAL" clId="{334A65D2-812A-5EDD-A5B2-F31A17A4407D}" dt="2026-09-15T00:49:06.286" v="24" actId="20577"/>
+        <pc:sldMkLst>
+          <pc:docMk/>
+          <pc:sldMk cId="2730065708" sldId="342"/>
+        </pc:sldMkLst>
+        <pc:spChg chg="add mod">
+          <ac:chgData name="Christopher Power" userId="83706efc-52ec-4aad-b93a-e27c6e901a30" providerId="ADAL" clId="{334A65D2-812A-5EDD-A5B2-F31A17A4407D}" dt="2026-09-15T00:49:06.286" v="24" actId="20577"/>
+          <ac:spMkLst>
+            <pc:docMk/>
+            <pc:sldMk cId="2730065708" sldId="342"/>
+            <ac:spMk id="3" creationId="{B1EF1DFE-C256-36FD-4B36-93ABD4322B6C}"/>
+          </ac:spMkLst>
+        </pc:spChg>
+        <pc:spChg chg="del">
+          <ac:chgData name="Christopher Power" userId="83706efc-52ec-4aad-b93a-e27c6e901a30" providerId="ADAL" clId="{334A65D2-812A-5EDD-A5B2-F31A17A4407D}" dt="2026-09-15T00:49:01.049" v="1" actId="478"/>
+          <ac:spMkLst>
+            <pc:docMk/>
+            <pc:sldMk cId="2730065708" sldId="342"/>
+            <ac:spMk id="6" creationId="{CB7BC1C2-4DF7-53F7-814C-B6F01E765F25}"/>
+          </ac:spMkLst>
+        </pc:spChg>
+        <pc:picChg chg="del">
+          <ac:chgData name="Christopher Power" userId="83706efc-52ec-4aad-b93a-e27c6e901a30" providerId="ADAL" clId="{334A65D2-812A-5EDD-A5B2-F31A17A4407D}" dt="2026-09-15T00:48:57.178" v="0" actId="478"/>
+          <ac:picMkLst>
+            <pc:docMk/>
+            <pc:sldMk cId="2730065708" sldId="342"/>
+            <ac:picMk id="2053" creationId="{D52CEEFB-86B0-4E44-EBEF-9B4E14C96456}"/>
+          </ac:picMkLst>
+        </pc:picChg>
       </pc:sldChg>
     </pc:docChg>
   </pc:docChgLst>
@@ -330,7 +376,7 @@
           <a:p>
             <a:fld id="{34AA4B8C-BF6B-4440-8121-9D39C04872C3}" type="datetimeFigureOut">
               <a:rPr lang="en-US" smtClean="0"/>
-              <a:t>9/3/2026</a:t>
+              <a:t>9/14/26</a:t>
             </a:fld>
             <a:endParaRPr lang="en-US"/>
           </a:p>
@@ -847,7 +893,7 @@
           <a:p>
             <a:fld id="{1160EA64-D806-43AC-9DF2-F8C432F32B4C}" type="datetimeFigureOut">
               <a:rPr lang="en-US" dirty="0"/>
-              <a:t>9/3/2026</a:t>
+              <a:t>9/14/26</a:t>
             </a:fld>
             <a:endParaRPr lang="en-US" dirty="0"/>
           </a:p>
@@ -1013,7 +1059,7 @@
           <a:p>
             <a:fld id="{E9F9C37B-1D36-470B-8223-D6C91242EC14}" type="datetimeFigureOut">
               <a:rPr lang="en-US" dirty="0"/>
-              <a:t>9/3/2026</a:t>
+              <a:t>9/14/26</a:t>
             </a:fld>
             <a:endParaRPr lang="en-US" dirty="0"/>
           </a:p>
@@ -1188,7 +1234,7 @@
           <a:p>
             <a:fld id="{67C6F52A-A82B-47A2-A83A-8C4C91F2D59F}" type="datetimeFigureOut">
               <a:rPr lang="en-US" dirty="0"/>
-              <a:t>9/3/2026</a:t>
+              <a:t>9/14/26</a:t>
             </a:fld>
             <a:endParaRPr lang="en-US" dirty="0"/>
           </a:p>
@@ -1353,7 +1399,7 @@
           <a:p>
             <a:fld id="{F070A7B3-6521-4DCA-87E5-044747A908C1}" type="datetimeFigureOut">
               <a:rPr lang="en-US" dirty="0"/>
-              <a:t>9/3/2026</a:t>
+              <a:t>9/14/26</a:t>
             </a:fld>
             <a:endParaRPr lang="en-US" dirty="0"/>
           </a:p>
@@ -1617,7 +1663,7 @@
           <a:p>
             <a:fld id="{1160EA64-D806-43AC-9DF2-F8C432F32B4C}" type="datetimeFigureOut">
               <a:rPr lang="en-US" dirty="0"/>
-              <a:t>9/3/2026</a:t>
+              <a:t>9/14/26</a:t>
             </a:fld>
             <a:endParaRPr lang="en-US" dirty="0"/>
           </a:p>
@@ -1845,7 +1891,7 @@
           <a:p>
             <a:fld id="{AB134690-1557-4C89-A502-4959FE7FAD70}" type="datetimeFigureOut">
               <a:rPr lang="en-US" dirty="0"/>
-              <a:t>9/3/2026</a:t>
+              <a:t>9/14/26</a:t>
             </a:fld>
             <a:endParaRPr lang="en-US" dirty="0"/>
           </a:p>
@@ -2199,7 +2245,7 @@
           <a:p>
             <a:fld id="{4F7D4976-E339-4826-83B7-FBD03F55ECF8}" type="datetimeFigureOut">
               <a:rPr lang="en-US" dirty="0"/>
-              <a:t>9/3/2026</a:t>
+              <a:t>9/14/26</a:t>
             </a:fld>
             <a:endParaRPr lang="en-US" dirty="0"/>
           </a:p>
@@ -2335,7 +2381,7 @@
           <a:p>
             <a:fld id="{E1037C31-9E7A-4F99-8774-A0E530DE1A42}" type="datetimeFigureOut">
               <a:rPr lang="en-US" dirty="0"/>
-              <a:t>9/3/2026</a:t>
+              <a:t>9/14/26</a:t>
             </a:fld>
             <a:endParaRPr lang="en-US" dirty="0"/>
           </a:p>
@@ -2425,7 +2471,7 @@
           <a:p>
             <a:fld id="{C278504F-A551-4DE0-9316-4DCD1D8CC752}" type="datetimeFigureOut">
               <a:rPr lang="en-US" dirty="0"/>
-              <a:t>9/3/2026</a:t>
+              <a:t>9/14/26</a:t>
             </a:fld>
             <a:endParaRPr lang="en-US" dirty="0"/>
           </a:p>
@@ -2777,7 +2823,7 @@
           <a:p>
             <a:fld id="{D1BE4249-C0D0-4B06-8692-E8BB871AF643}" type="datetimeFigureOut">
               <a:rPr lang="en-US" dirty="0"/>
-              <a:t>9/3/2026</a:t>
+              <a:t>9/14/26</a:t>
             </a:fld>
             <a:endParaRPr lang="en-US" dirty="0"/>
           </a:p>
@@ -3129,7 +3175,7 @@
           <a:p>
             <a:fld id="{042B0DB6-F5C7-45FB-8CF3-31B45F9C2DAC}" type="datetimeFigureOut">
               <a:rPr lang="en-US" dirty="0"/>
-              <a:t>9/3/2026</a:t>
+              <a:t>9/14/26</a:t>
             </a:fld>
             <a:endParaRPr lang="en-US" dirty="0"/>
           </a:p>
@@ -3366,7 +3412,7 @@
           <a:p>
             <a:fld id="{1160EA64-D806-43AC-9DF2-F8C432F32B4C}" type="datetimeFigureOut">
               <a:rPr lang="en-US" dirty="0"/>
-              <a:t>9/3/2026</a:t>
+              <a:t>9/14/26</a:t>
             </a:fld>
             <a:endParaRPr lang="en-US" dirty="0"/>
           </a:p>
@@ -10953,161 +10999,32 @@
       </p:sp>
       <p:sp>
         <p:nvSpPr>
-          <p:cNvPr id="6" name="Rectangle 3">
-            <a:extLst>
-              <a:ext uri="{FF2B5EF4-FFF2-40B4-BE49-F238E27FC236}">
-                <a16:creationId xmlns:a16="http://schemas.microsoft.com/office/drawing/2014/main" id="{CB7BC1C2-4DF7-53F7-814C-B6F01E765F25}"/>
+          <p:cNvPr id="3" name="Content Placeholder 2">
+            <a:extLst>
+              <a:ext uri="{FF2B5EF4-FFF2-40B4-BE49-F238E27FC236}">
+                <a16:creationId xmlns:a16="http://schemas.microsoft.com/office/drawing/2014/main" id="{B1EF1DFE-C256-36FD-4B36-93ABD4322B6C}"/>
               </a:ext>
             </a:extLst>
           </p:cNvPr>
           <p:cNvSpPr>
-            <a:spLocks noGrp="1" noChangeArrowheads="1"/>
+            <a:spLocks noGrp="1"/>
           </p:cNvSpPr>
           <p:nvPr>
             <p:ph idx="1"/>
           </p:nvPr>
         </p:nvSpPr>
-        <p:spPr bwMode="auto">
-          <a:xfrm>
-            <a:off x="1759034" y="2525524"/>
-            <a:ext cx="8673931" cy="369332"/>
-          </a:xfrm>
-          <a:prstGeom prst="rect">
-            <a:avLst/>
-          </a:prstGeom>
-          <a:noFill/>
-          <a:ln>
-            <a:noFill/>
-          </a:ln>
-          <a:effectLst/>
-          <a:extLst>
-            <a:ext uri="{909E8E84-426E-40DD-AFC4-6F175D3DCCD1}">
-              <a14:hiddenFill xmlns:a14="http://schemas.microsoft.com/office/drawing/2010/main">
-                <a:solidFill>
-                  <a:schemeClr val="accent1"/>
-                </a:solidFill>
-              </a14:hiddenFill>
-            </a:ext>
-            <a:ext uri="{91240B29-F687-4F45-9708-019B960494DF}">
-              <a14:hiddenLine xmlns:a14="http://schemas.microsoft.com/office/drawing/2010/main" w="9525">
-                <a:solidFill>
-                  <a:schemeClr val="tx1"/>
-                </a:solidFill>
-                <a:miter lim="800000"/>
-                <a:headEnd/>
-                <a:tailEnd/>
-              </a14:hiddenLine>
-            </a:ext>
-            <a:ext uri="{AF507438-7753-43E0-B8FC-AC1667EBCBE1}">
-              <a14:hiddenEffects xmlns:a14="http://schemas.microsoft.com/office/drawing/2010/main">
-                <a:effectLst>
-                  <a:outerShdw dist="35921" dir="2700000" algn="ctr" rotWithShape="0">
-                    <a:schemeClr val="bg2"/>
-                  </a:outerShdw>
-                </a:effectLst>
-              </a14:hiddenEffects>
-            </a:ext>
-          </a:extLst>
-        </p:spPr>
-        <p:txBody>
-          <a:bodyPr vert="horz" wrap="square" lIns="91440" tIns="45720" rIns="91440" bIns="45720" numCol="1" anchor="ctr" anchorCtr="0" compatLnSpc="1">
-            <a:prstTxWarp prst="textNoShape">
-              <a:avLst/>
-            </a:prstTxWarp>
-            <a:spAutoFit/>
-          </a:bodyPr>
-          <a:lstStyle/>
-          <a:p>
-            <a:pPr marL="0" marR="0" lvl="0" indent="0" algn="l" defTabSz="914400" rtl="0" eaLnBrk="0" fontAlgn="base" latinLnBrk="0" hangingPunct="0">
-              <a:lnSpc>
-                <a:spcPct val="100000"/>
-              </a:lnSpc>
-              <a:spcBef>
-                <a:spcPct val="0"/>
-              </a:spcBef>
-              <a:spcAft>
-                <a:spcPct val="0"/>
-              </a:spcAft>
-              <a:buClrTx/>
-              <a:buSzTx/>
-              <a:buFontTx/>
-              <a:buNone/>
-              <a:tabLst/>
-            </a:pPr>
-            <a:r>
-              <a:rPr kumimoji="0" lang="en-US" altLang="en-US" sz="1800" b="0" i="0" u="none" strike="noStrike" cap="none" normalizeH="0" baseline="0" dirty="0">
-                <a:ln>
-                  <a:noFill/>
-                </a:ln>
-                <a:solidFill>
-                  <a:schemeClr val="tx1"/>
-                </a:solidFill>
-                <a:effectLst/>
-                <a:latin typeface="Arial" panose="020B0604020202020204" pitchFamily="34" charset="0"/>
-                <a:hlinkClick r:id="rId2"/>
-              </a:rPr>
-              <a:t>2026W CS1910 03 In-Class Participation Computational Thinking – Fill out form</a:t>
-            </a:r>
-            <a:endParaRPr kumimoji="0" lang="en-US" altLang="en-US" sz="1800" b="0" i="0" u="none" strike="noStrike" cap="none" normalizeH="0" baseline="0" dirty="0">
-              <a:ln>
-                <a:noFill/>
-              </a:ln>
-              <a:solidFill>
-                <a:schemeClr val="tx1"/>
-              </a:solidFill>
-              <a:effectLst/>
-              <a:latin typeface="Arial" panose="020B0604020202020204" pitchFamily="34" charset="0"/>
-            </a:endParaRPr>
-          </a:p>
-        </p:txBody>
-      </p:sp>
-      <p:pic>
-        <p:nvPicPr>
-          <p:cNvPr id="2053" name="Picture 5" descr="QR code">
-            <a:extLst>
-              <a:ext uri="{FF2B5EF4-FFF2-40B4-BE49-F238E27FC236}">
-                <a16:creationId xmlns:a16="http://schemas.microsoft.com/office/drawing/2014/main" id="{D52CEEFB-86B0-4E44-EBEF-9B4E14C96456}"/>
-              </a:ext>
-            </a:extLst>
-          </p:cNvPr>
-          <p:cNvPicPr>
-            <a:picLocks noChangeAspect="1" noChangeArrowheads="1"/>
-          </p:cNvPicPr>
-          <p:nvPr/>
-        </p:nvPicPr>
-        <p:blipFill>
-          <a:blip r:embed="rId3">
-            <a:extLst>
-              <a:ext uri="{28A0092B-C50C-407E-A947-70E740481C1C}">
-                <a14:useLocalDpi xmlns:a14="http://schemas.microsoft.com/office/drawing/2010/main" val="0"/>
-              </a:ext>
-            </a:extLst>
-          </a:blip>
-          <a:srcRect/>
-          <a:stretch>
-            <a:fillRect/>
-          </a:stretch>
-        </p:blipFill>
-        <p:spPr bwMode="auto">
-          <a:xfrm>
-            <a:off x="4601660" y="3081868"/>
-            <a:ext cx="2988678" cy="2988678"/>
-          </a:xfrm>
-          <a:prstGeom prst="rect">
-            <a:avLst/>
-          </a:prstGeom>
-          <a:noFill/>
-          <a:extLst>
-            <a:ext uri="{909E8E84-426E-40DD-AFC4-6F175D3DCCD1}">
-              <a14:hiddenFill xmlns:a14="http://schemas.microsoft.com/office/drawing/2010/main">
-                <a:solidFill>
-                  <a:srgbClr val="FFFFFF"/>
-                </a:solidFill>
-              </a14:hiddenFill>
-            </a:ext>
-          </a:extLst>
-        </p:spPr>
-      </p:pic>
+        <p:spPr/>
+        <p:txBody>
+          <a:bodyPr/>
+          <a:lstStyle/>
+          <a:p>
+            <a:r>
+              <a:rPr lang="en-US" dirty="0"/>
+              <a:t>See the link on Moodle!</a:t>
+            </a:r>
+          </a:p>
+        </p:txBody>
+      </p:sp>
     </p:spTree>
     <p:extLst>
       <p:ext uri="{BB962C8B-B14F-4D97-AF65-F5344CB8AC3E}">
@@ -14155,7 +14072,7 @@
               <a:rPr lang="en-US" dirty="0">
                 <a:hlinkClick r:id="rId2"/>
               </a:rPr>
-              <a:t>https://colab.research.google.com/github/cdspower-upei/2026W-CS1910-Students/blob/main/Lectures/L03/L03-Examples.ipynb</a:t>
+              <a:t>https://colab.research.google.com/github/UPEI-CS/CS1910-Students/blob/main/lectures/03-Variables-Literals-Types/CS1910_Variables-Literals-Types_Workbook.ipynb</a:t>
             </a:r>
             <a:endParaRPr lang="en-US" dirty="0"/>
           </a:p>
@@ -14303,102 +14220,6 @@
     <p:extLst>
       <p:ext uri="{BB962C8B-B14F-4D97-AF65-F5344CB8AC3E}">
         <p14:creationId xmlns:p14="http://schemas.microsoft.com/office/powerpoint/2010/main" val="1322347579"/>
-      </p:ext>
-    </p:extLst>
-  </p:cSld>
-  <p:clrMapOvr>
-    <a:masterClrMapping/>
-  </p:clrMapOvr>
-</p:sld>
-</file>
-
-<file path=ppt/slides/slide36.xml><?xml version="1.0" encoding="utf-8"?>
-<p:sld xmlns:a="http://schemas.openxmlformats.org/drawingml/2006/main" xmlns:r="http://schemas.openxmlformats.org/officeDocument/2006/relationships" xmlns:p="http://schemas.openxmlformats.org/presentationml/2006/main">
-  <p:cSld>
-    <p:spTree>
-      <p:nvGrpSpPr>
-        <p:cNvPr id="1" name=""/>
-        <p:cNvGrpSpPr/>
-        <p:nvPr/>
-      </p:nvGrpSpPr>
-      <p:grpSpPr>
-        <a:xfrm>
-          <a:off x="0" y="0"/>
-          <a:ext cx="0" cy="0"/>
-          <a:chOff x="0" y="0"/>
-          <a:chExt cx="0" cy="0"/>
-        </a:xfrm>
-      </p:grpSpPr>
-      <p:sp>
-        <p:nvSpPr>
-          <p:cNvPr id="2" name="Title 1">
-            <a:extLst>
-              <a:ext uri="{FF2B5EF4-FFF2-40B4-BE49-F238E27FC236}">
-                <a16:creationId xmlns:a16="http://schemas.microsoft.com/office/drawing/2014/main" id="{2D382ADF-2A07-6801-0BD9-AAF4DDE2AECD}"/>
-              </a:ext>
-            </a:extLst>
-          </p:cNvPr>
-          <p:cNvSpPr>
-            <a:spLocks noGrp="1"/>
-          </p:cNvSpPr>
-          <p:nvPr>
-            <p:ph type="title"/>
-          </p:nvPr>
-        </p:nvSpPr>
-        <p:spPr/>
-        <p:txBody>
-          <a:bodyPr/>
-          <a:lstStyle/>
-          <a:p>
-            <a:r>
-              <a:rPr lang="en-US" dirty="0" err="1"/>
-              <a:t>HomeWork</a:t>
-            </a:r>
-            <a:r>
-              <a:rPr lang="en-US" dirty="0"/>
-              <a:t> 2</a:t>
-            </a:r>
-          </a:p>
-        </p:txBody>
-      </p:sp>
-      <p:sp>
-        <p:nvSpPr>
-          <p:cNvPr id="3" name="Content Placeholder 2">
-            <a:extLst>
-              <a:ext uri="{FF2B5EF4-FFF2-40B4-BE49-F238E27FC236}">
-                <a16:creationId xmlns:a16="http://schemas.microsoft.com/office/drawing/2014/main" id="{33DD9E32-8675-AF19-4C5E-F5C749E2B197}"/>
-              </a:ext>
-            </a:extLst>
-          </p:cNvPr>
-          <p:cNvSpPr>
-            <a:spLocks noGrp="1"/>
-          </p:cNvSpPr>
-          <p:nvPr>
-            <p:ph idx="1"/>
-          </p:nvPr>
-        </p:nvSpPr>
-        <p:spPr/>
-        <p:txBody>
-          <a:bodyPr/>
-          <a:lstStyle/>
-          <a:p>
-            <a:r>
-              <a:rPr lang="en-US" dirty="0">
-                <a:hlinkClick r:id="rId2"/>
-              </a:rPr>
-              <a:t>https://colab.research.google.com/github/cdspower-upei/2026W-CS1910-Students/blob/main/Homework/HW02/HW-02.ipynb</a:t>
-            </a:r>
-            <a:endParaRPr lang="en-US" dirty="0"/>
-          </a:p>
-          <a:p>
-            <a:endParaRPr lang="en-US" dirty="0"/>
-          </a:p>
-        </p:txBody>
-      </p:sp>
-    </p:spTree>
-    <p:extLst>
-      <p:ext uri="{BB962C8B-B14F-4D97-AF65-F5344CB8AC3E}">
-        <p14:creationId xmlns:p14="http://schemas.microsoft.com/office/powerpoint/2010/main" val="2027712955"/>
       </p:ext>
     </p:extLst>
   </p:cSld>

</xml_diff>